<commit_message>
Restyle the architecture slide to match the rest of the deck
The opening slide was the only dark one and used its own vocabulary. It
now uses the same light canvas, header treatment and node styling as every
other slide: tone-coded icon plates per layer, light panels with the
standard border and shadow, muted body text and the standard legend.

Each layer also carries its own tone (interfaces blue, orchestration
slate, pipelines violet, services cyan, storage green), and the component
pills shrink to fit only where a row would otherwise cross the margin.

Co-Authored-By: Claude Opus 5 <noreply@anthropic.com>
Claude-Session: https://claude.ai/code/session_01UKxe7sTh6HyfNySLBtnjKN
</commit_message>
<xml_diff>
--- a/docs/decks/arp-functions-and-architecture.pptx
+++ b/docs/decks/arp-functions-and-architecture.pptx
@@ -2637,7 +2637,7 @@
     <p:bg>
       <p:bgPr>
         <a:solidFill>
-          <a:srgbClr val="10243A"/>
+          <a:srgbClr val="FFFFFF"/>
         </a:solidFill>
       </p:bgPr>
     </p:bg>
@@ -2682,7 +2682,7 @@
             <a:r>
               <a:rPr lang="en-US" sz="1050" b="1" spc="200" kern="0" dirty="0">
                 <a:solidFill>
-                  <a:srgbClr val="E0A526"/>
+                  <a:srgbClr val="108494"/>
                 </a:solidFill>
                 <a:latin typeface="Calibri" pitchFamily="34" charset="0"/>
                 <a:ea typeface="Calibri" pitchFamily="34" charset="-122"/>
@@ -2721,7 +2721,7 @@
             <a:r>
               <a:rPr lang="en-US" sz="3000" b="1" dirty="0">
                 <a:solidFill>
-                  <a:srgbClr val="FFFFFF"/>
+                  <a:srgbClr val="10243A"/>
                 </a:solidFill>
                 <a:latin typeface="Cambria" pitchFamily="34" charset="0"/>
                 <a:ea typeface="Cambria" pitchFamily="34" charset="-122"/>
@@ -2760,7 +2760,7 @@
             <a:r>
               <a:rPr lang="en-US" sz="1200" dirty="0">
                 <a:solidFill>
-                  <a:srgbClr val="B9CDDD"/>
+                  <a:srgbClr val="58697A"/>
                 </a:solidFill>
                 <a:latin typeface="Calibri" pitchFamily="34" charset="0"/>
                 <a:ea typeface="Calibri" pitchFamily="34" charset="-122"/>
@@ -2789,7 +2789,7 @@
             </a:avLst>
           </a:prstGeom>
           <a:solidFill>
-            <a:srgbClr val="23496D"/>
+            <a:srgbClr val="10243A"/>
           </a:solidFill>
           <a:ln/>
         </p:spPr>
@@ -2831,18 +2831,25 @@
           </a:xfrm>
           <a:prstGeom prst="roundRect">
             <a:avLst>
-              <a:gd name="adj" fmla="val 4878"/>
+              <a:gd name="adj" fmla="val 12195"/>
             </a:avLst>
           </a:prstGeom>
           <a:solidFill>
-            <a:srgbClr val="1E3F5E"/>
+            <a:srgbClr val="F8FAFC"/>
           </a:solidFill>
-          <a:ln w="12700">
-            <a:solidFill>
-              <a:srgbClr val="2F5A80"/>
+          <a:ln w="15875">
+            <a:solidFill>
+              <a:srgbClr val="AECBF2"/>
             </a:solidFill>
             <a:prstDash val="solid"/>
           </a:ln>
+          <a:effectLst>
+            <a:outerShdw sx="100000" sy="100000" kx="0" ky="0" algn="bl" rotWithShape="0" blurRad="101600" dist="19050" dir="5400000">
+              <a:srgbClr val="9FB0C2">
+                <a:alpha val="24000"/>
+              </a:srgbClr>
+            </a:outerShdw>
+          </a:effectLst>
         </p:spPr>
       </p:sp>
       <p:sp>
@@ -2862,7 +2869,7 @@
             </a:avLst>
           </a:prstGeom>
           <a:solidFill>
-            <a:srgbClr val="2C5B85"/>
+            <a:srgbClr val="2F6FD0"/>
           </a:solidFill>
           <a:ln/>
         </p:spPr>
@@ -2900,7 +2907,7 @@
         <p:spPr>
           <a:xfrm>
             <a:off x="1344168" y="1600200"/>
-            <a:ext cx="1600200" cy="237744"/>
+            <a:ext cx="1874520" cy="237744"/>
           </a:xfrm>
           <a:prstGeom prst="rect">
             <a:avLst/>
@@ -2918,7 +2925,7 @@
             <a:r>
               <a:rPr lang="en-US" sz="1250" b="1" dirty="0">
                 <a:solidFill>
-                  <a:srgbClr val="C9871B"/>
+                  <a:srgbClr val="153A61"/>
                 </a:solidFill>
                 <a:latin typeface="Cambria" pitchFamily="34" charset="0"/>
                 <a:ea typeface="Cambria" pitchFamily="34" charset="-122"/>
@@ -2939,7 +2946,7 @@
         <p:spPr>
           <a:xfrm>
             <a:off x="1344168" y="1865376"/>
-            <a:ext cx="1600200" cy="201168"/>
+            <a:ext cx="1874520" cy="201168"/>
           </a:xfrm>
           <a:prstGeom prst="rect">
             <a:avLst/>
@@ -2957,7 +2964,7 @@
             <a:r>
               <a:rPr lang="en-US" sz="850" i="1" dirty="0">
                 <a:solidFill>
-                  <a:srgbClr val="B9CDDD"/>
+                  <a:srgbClr val="58697A"/>
                 </a:solidFill>
                 <a:latin typeface="Calibri" pitchFamily="34" charset="0"/>
                 <a:ea typeface="Calibri" pitchFamily="34" charset="-122"/>
@@ -2977,8 +2984,8 @@
         </p:nvSpPr>
         <p:spPr>
           <a:xfrm>
-            <a:off x="2990088" y="1591056"/>
-            <a:ext cx="1245413" cy="274320"/>
+            <a:off x="3264408" y="1591056"/>
+            <a:ext cx="1281989" cy="274320"/>
           </a:xfrm>
           <a:prstGeom prst="roundRect">
             <a:avLst>
@@ -3004,8 +3011,8 @@
         </p:nvSpPr>
         <p:spPr>
           <a:xfrm>
-            <a:off x="2990088" y="1591056"/>
-            <a:ext cx="1245413" cy="274320"/>
+            <a:off x="3264408" y="1591056"/>
+            <a:ext cx="1281989" cy="274320"/>
           </a:xfrm>
           <a:prstGeom prst="rect">
             <a:avLst/>
@@ -3043,8 +3050,8 @@
         </p:nvSpPr>
         <p:spPr>
           <a:xfrm>
-            <a:off x="4336085" y="1591056"/>
-            <a:ext cx="1298448" cy="274320"/>
+            <a:off x="4646981" y="1591056"/>
+            <a:ext cx="1335024" cy="274320"/>
           </a:xfrm>
           <a:prstGeom prst="roundRect">
             <a:avLst>
@@ -3070,8 +3077,8 @@
         </p:nvSpPr>
         <p:spPr>
           <a:xfrm>
-            <a:off x="4336085" y="1591056"/>
-            <a:ext cx="1298448" cy="274320"/>
+            <a:off x="4646981" y="1591056"/>
+            <a:ext cx="1335024" cy="274320"/>
           </a:xfrm>
           <a:prstGeom prst="rect">
             <a:avLst/>
@@ -3109,8 +3116,8 @@
         </p:nvSpPr>
         <p:spPr>
           <a:xfrm>
-            <a:off x="5735117" y="1591056"/>
-            <a:ext cx="715061" cy="274320"/>
+            <a:off x="6082589" y="1591056"/>
+            <a:ext cx="751637" cy="274320"/>
           </a:xfrm>
           <a:prstGeom prst="roundRect">
             <a:avLst>
@@ -3136,8 +3143,8 @@
         </p:nvSpPr>
         <p:spPr>
           <a:xfrm>
-            <a:off x="5735117" y="1591056"/>
-            <a:ext cx="715061" cy="274320"/>
+            <a:off x="6082589" y="1591056"/>
+            <a:ext cx="751637" cy="274320"/>
           </a:xfrm>
           <a:prstGeom prst="rect">
             <a:avLst/>
@@ -3175,8 +3182,8 @@
         </p:nvSpPr>
         <p:spPr>
           <a:xfrm>
-            <a:off x="2990088" y="1938528"/>
-            <a:ext cx="8348472" cy="219456"/>
+            <a:off x="3264408" y="1938528"/>
+            <a:ext cx="8074152" cy="219456"/>
           </a:xfrm>
           <a:prstGeom prst="rect">
             <a:avLst/>
@@ -3194,7 +3201,7 @@
             <a:r>
               <a:rPr lang="en-US" sz="880" dirty="0">
                 <a:solidFill>
-                  <a:srgbClr val="B9CDDD"/>
+                  <a:srgbClr val="43566B"/>
                 </a:solidFill>
                 <a:latin typeface="Calibri" pitchFamily="34" charset="0"/>
                 <a:ea typeface="Calibri" pitchFamily="34" charset="-122"/>
@@ -3223,7 +3230,7 @@
           <a:noFill/>
           <a:ln w="17780">
             <a:solidFill>
-              <a:srgbClr val="4E7CA6"/>
+              <a:srgbClr val="64798F"/>
             </a:solidFill>
             <a:prstDash val="solid"/>
             <a:headEnd type="none"/>
@@ -3244,18 +3251,25 @@
           </a:xfrm>
           <a:prstGeom prst="roundRect">
             <a:avLst>
-              <a:gd name="adj" fmla="val 4878"/>
+              <a:gd name="adj" fmla="val 12195"/>
             </a:avLst>
           </a:prstGeom>
           <a:solidFill>
-            <a:srgbClr val="1E3F5E"/>
+            <a:srgbClr val="F8FAFC"/>
           </a:solidFill>
-          <a:ln w="12700">
-            <a:solidFill>
-              <a:srgbClr val="2F5A80"/>
+          <a:ln w="15875">
+            <a:solidFill>
+              <a:srgbClr val="C8D4E0"/>
             </a:solidFill>
             <a:prstDash val="solid"/>
           </a:ln>
+          <a:effectLst>
+            <a:outerShdw sx="100000" sy="100000" kx="0" ky="0" algn="bl" rotWithShape="0" blurRad="101600" dist="19050" dir="5400000">
+              <a:srgbClr val="9FB0C2">
+                <a:alpha val="24000"/>
+              </a:srgbClr>
+            </a:outerShdw>
+          </a:effectLst>
         </p:spPr>
       </p:sp>
       <p:sp>
@@ -3275,7 +3289,7 @@
             </a:avLst>
           </a:prstGeom>
           <a:solidFill>
-            <a:srgbClr val="2C5B85"/>
+            <a:srgbClr val="64798F"/>
           </a:solidFill>
           <a:ln/>
         </p:spPr>
@@ -3313,7 +3327,7 @@
         <p:spPr>
           <a:xfrm>
             <a:off x="1344168" y="2519172"/>
-            <a:ext cx="1600200" cy="237744"/>
+            <a:ext cx="1874520" cy="237744"/>
           </a:xfrm>
           <a:prstGeom prst="rect">
             <a:avLst/>
@@ -3331,7 +3345,7 @@
             <a:r>
               <a:rPr lang="en-US" sz="1250" b="1" dirty="0">
                 <a:solidFill>
-                  <a:srgbClr val="C9871B"/>
+                  <a:srgbClr val="24354A"/>
                 </a:solidFill>
                 <a:latin typeface="Cambria" pitchFamily="34" charset="0"/>
                 <a:ea typeface="Cambria" pitchFamily="34" charset="-122"/>
@@ -3352,7 +3366,7 @@
         <p:spPr>
           <a:xfrm>
             <a:off x="1344168" y="2784348"/>
-            <a:ext cx="1600200" cy="201168"/>
+            <a:ext cx="1874520" cy="201168"/>
           </a:xfrm>
           <a:prstGeom prst="rect">
             <a:avLst/>
@@ -3370,7 +3384,7 @@
             <a:r>
               <a:rPr lang="en-US" sz="850" i="1" dirty="0">
                 <a:solidFill>
-                  <a:srgbClr val="B9CDDD"/>
+                  <a:srgbClr val="58697A"/>
                 </a:solidFill>
                 <a:latin typeface="Calibri" pitchFamily="34" charset="0"/>
                 <a:ea typeface="Calibri" pitchFamily="34" charset="-122"/>
@@ -3390,8 +3404,8 @@
         </p:nvSpPr>
         <p:spPr>
           <a:xfrm>
-            <a:off x="2990088" y="2510028"/>
-            <a:ext cx="768096" cy="274320"/>
+            <a:off x="3264408" y="2510028"/>
+            <a:ext cx="804672" cy="274320"/>
           </a:xfrm>
           <a:prstGeom prst="roundRect">
             <a:avLst>
@@ -3417,8 +3431,8 @@
         </p:nvSpPr>
         <p:spPr>
           <a:xfrm>
-            <a:off x="2990088" y="2510028"/>
-            <a:ext cx="768096" cy="274320"/>
+            <a:off x="3264408" y="2510028"/>
+            <a:ext cx="804672" cy="274320"/>
           </a:xfrm>
           <a:prstGeom prst="rect">
             <a:avLst/>
@@ -3456,8 +3470,8 @@
         </p:nvSpPr>
         <p:spPr>
           <a:xfrm>
-            <a:off x="3858768" y="2510028"/>
-            <a:ext cx="821131" cy="274320"/>
+            <a:off x="4169664" y="2510028"/>
+            <a:ext cx="857707" cy="274320"/>
           </a:xfrm>
           <a:prstGeom prst="roundRect">
             <a:avLst>
@@ -3483,8 +3497,8 @@
         </p:nvSpPr>
         <p:spPr>
           <a:xfrm>
-            <a:off x="3858768" y="2510028"/>
-            <a:ext cx="821131" cy="274320"/>
+            <a:off x="4169664" y="2510028"/>
+            <a:ext cx="857707" cy="274320"/>
           </a:xfrm>
           <a:prstGeom prst="rect">
             <a:avLst/>
@@ -3522,8 +3536,8 @@
         </p:nvSpPr>
         <p:spPr>
           <a:xfrm>
-            <a:off x="4780483" y="2510028"/>
-            <a:ext cx="715061" cy="274320"/>
+            <a:off x="5127955" y="2510028"/>
+            <a:ext cx="751637" cy="274320"/>
           </a:xfrm>
           <a:prstGeom prst="roundRect">
             <a:avLst>
@@ -3549,8 +3563,8 @@
         </p:nvSpPr>
         <p:spPr>
           <a:xfrm>
-            <a:off x="4780483" y="2510028"/>
-            <a:ext cx="715061" cy="274320"/>
+            <a:off x="5127955" y="2510028"/>
+            <a:ext cx="751637" cy="274320"/>
           </a:xfrm>
           <a:prstGeom prst="rect">
             <a:avLst/>
@@ -3588,8 +3602,8 @@
         </p:nvSpPr>
         <p:spPr>
           <a:xfrm>
-            <a:off x="5596128" y="2510028"/>
-            <a:ext cx="874166" cy="274320"/>
+            <a:off x="5980176" y="2510028"/>
+            <a:ext cx="910742" cy="274320"/>
           </a:xfrm>
           <a:prstGeom prst="roundRect">
             <a:avLst>
@@ -3615,8 +3629,8 @@
         </p:nvSpPr>
         <p:spPr>
           <a:xfrm>
-            <a:off x="5596128" y="2510028"/>
-            <a:ext cx="874166" cy="274320"/>
+            <a:off x="5980176" y="2510028"/>
+            <a:ext cx="910742" cy="274320"/>
           </a:xfrm>
           <a:prstGeom prst="rect">
             <a:avLst/>
@@ -3654,8 +3668,8 @@
         </p:nvSpPr>
         <p:spPr>
           <a:xfrm>
-            <a:off x="6570878" y="2510028"/>
-            <a:ext cx="874166" cy="274320"/>
+            <a:off x="6991502" y="2510028"/>
+            <a:ext cx="910742" cy="274320"/>
           </a:xfrm>
           <a:prstGeom prst="roundRect">
             <a:avLst>
@@ -3681,8 +3695,8 @@
         </p:nvSpPr>
         <p:spPr>
           <a:xfrm>
-            <a:off x="6570878" y="2510028"/>
-            <a:ext cx="874166" cy="274320"/>
+            <a:off x="6991502" y="2510028"/>
+            <a:ext cx="910742" cy="274320"/>
           </a:xfrm>
           <a:prstGeom prst="rect">
             <a:avLst/>
@@ -3720,8 +3734,8 @@
         </p:nvSpPr>
         <p:spPr>
           <a:xfrm>
-            <a:off x="2990088" y="2857500"/>
-            <a:ext cx="8348472" cy="219456"/>
+            <a:off x="3264408" y="2857500"/>
+            <a:ext cx="8074152" cy="219456"/>
           </a:xfrm>
           <a:prstGeom prst="rect">
             <a:avLst/>
@@ -3739,7 +3753,7 @@
             <a:r>
               <a:rPr lang="en-US" sz="880" dirty="0">
                 <a:solidFill>
-                  <a:srgbClr val="B9CDDD"/>
+                  <a:srgbClr val="43566B"/>
                 </a:solidFill>
                 <a:latin typeface="Calibri" pitchFamily="34" charset="0"/>
                 <a:ea typeface="Calibri" pitchFamily="34" charset="-122"/>
@@ -3768,7 +3782,7 @@
           <a:noFill/>
           <a:ln w="17780">
             <a:solidFill>
-              <a:srgbClr val="4E7CA6"/>
+              <a:srgbClr val="64798F"/>
             </a:solidFill>
             <a:prstDash val="solid"/>
             <a:headEnd type="none"/>
@@ -3789,18 +3803,25 @@
           </a:xfrm>
           <a:prstGeom prst="roundRect">
             <a:avLst>
-              <a:gd name="adj" fmla="val 4878"/>
+              <a:gd name="adj" fmla="val 12195"/>
             </a:avLst>
           </a:prstGeom>
           <a:solidFill>
-            <a:srgbClr val="1E3F5E"/>
+            <a:srgbClr val="F8FAFC"/>
           </a:solidFill>
-          <a:ln w="12700">
-            <a:solidFill>
-              <a:srgbClr val="2F5A80"/>
+          <a:ln w="15875">
+            <a:solidFill>
+              <a:srgbClr val="C9BAF4"/>
             </a:solidFill>
             <a:prstDash val="solid"/>
           </a:ln>
+          <a:effectLst>
+            <a:outerShdw sx="100000" sy="100000" kx="0" ky="0" algn="bl" rotWithShape="0" blurRad="101600" dist="19050" dir="5400000">
+              <a:srgbClr val="9FB0C2">
+                <a:alpha val="24000"/>
+              </a:srgbClr>
+            </a:outerShdw>
+          </a:effectLst>
         </p:spPr>
       </p:sp>
       <p:sp>
@@ -3820,7 +3841,7 @@
             </a:avLst>
           </a:prstGeom>
           <a:solidFill>
-            <a:srgbClr val="2C5B85"/>
+            <a:srgbClr val="6D4DD1"/>
           </a:solidFill>
           <a:ln/>
         </p:spPr>
@@ -3858,7 +3879,7 @@
         <p:spPr>
           <a:xfrm>
             <a:off x="1344168" y="3438144"/>
-            <a:ext cx="1600200" cy="237744"/>
+            <a:ext cx="1874520" cy="237744"/>
           </a:xfrm>
           <a:prstGeom prst="rect">
             <a:avLst/>
@@ -3876,7 +3897,7 @@
             <a:r>
               <a:rPr lang="en-US" sz="1250" b="1" dirty="0">
                 <a:solidFill>
-                  <a:srgbClr val="C9871B"/>
+                  <a:srgbClr val="35236E"/>
                 </a:solidFill>
                 <a:latin typeface="Cambria" pitchFamily="34" charset="0"/>
                 <a:ea typeface="Cambria" pitchFamily="34" charset="-122"/>
@@ -3897,7 +3918,7 @@
         <p:spPr>
           <a:xfrm>
             <a:off x="1344168" y="3703320"/>
-            <a:ext cx="1600200" cy="201168"/>
+            <a:ext cx="1874520" cy="201168"/>
           </a:xfrm>
           <a:prstGeom prst="rect">
             <a:avLst/>
@@ -3915,7 +3936,7 @@
             <a:r>
               <a:rPr lang="en-US" sz="850" i="1" dirty="0">
                 <a:solidFill>
-                  <a:srgbClr val="B9CDDD"/>
+                  <a:srgbClr val="58697A"/>
                 </a:solidFill>
                 <a:latin typeface="Calibri" pitchFamily="34" charset="0"/>
                 <a:ea typeface="Calibri" pitchFamily="34" charset="-122"/>
@@ -3935,8 +3956,8 @@
         </p:nvSpPr>
         <p:spPr>
           <a:xfrm>
-            <a:off x="2990088" y="3429000"/>
-            <a:ext cx="502920" cy="274320"/>
+            <a:off x="3264408" y="3429000"/>
+            <a:ext cx="501110" cy="274320"/>
           </a:xfrm>
           <a:prstGeom prst="roundRect">
             <a:avLst>
@@ -3962,8 +3983,8 @@
         </p:nvSpPr>
         <p:spPr>
           <a:xfrm>
-            <a:off x="2990088" y="3429000"/>
-            <a:ext cx="502920" cy="274320"/>
+            <a:off x="3264408" y="3429000"/>
+            <a:ext cx="501110" cy="274320"/>
           </a:xfrm>
           <a:prstGeom prst="rect">
             <a:avLst/>
@@ -4001,8 +4022,8 @@
         </p:nvSpPr>
         <p:spPr>
           <a:xfrm>
-            <a:off x="3593592" y="3429000"/>
-            <a:ext cx="768096" cy="274320"/>
+            <a:off x="3866102" y="3429000"/>
+            <a:ext cx="747419" cy="274320"/>
           </a:xfrm>
           <a:prstGeom prst="roundRect">
             <a:avLst>
@@ -4028,8 +4049,8 @@
         </p:nvSpPr>
         <p:spPr>
           <a:xfrm>
-            <a:off x="3593592" y="3429000"/>
-            <a:ext cx="768096" cy="274320"/>
+            <a:off x="3866102" y="3429000"/>
+            <a:ext cx="747419" cy="274320"/>
           </a:xfrm>
           <a:prstGeom prst="rect">
             <a:avLst/>
@@ -4067,8 +4088,8 @@
         </p:nvSpPr>
         <p:spPr>
           <a:xfrm>
-            <a:off x="4462272" y="3429000"/>
-            <a:ext cx="768096" cy="274320"/>
+            <a:off x="4714105" y="3429000"/>
+            <a:ext cx="747419" cy="274320"/>
           </a:xfrm>
           <a:prstGeom prst="roundRect">
             <a:avLst>
@@ -4094,8 +4115,8 @@
         </p:nvSpPr>
         <p:spPr>
           <a:xfrm>
-            <a:off x="4462272" y="3429000"/>
-            <a:ext cx="768096" cy="274320"/>
+            <a:off x="4714105" y="3429000"/>
+            <a:ext cx="747419" cy="274320"/>
           </a:xfrm>
           <a:prstGeom prst="rect">
             <a:avLst/>
@@ -4133,8 +4154,8 @@
         </p:nvSpPr>
         <p:spPr>
           <a:xfrm>
-            <a:off x="5330952" y="3429000"/>
-            <a:ext cx="715061" cy="274320"/>
+            <a:off x="5562108" y="3429000"/>
+            <a:ext cx="698157" cy="274320"/>
           </a:xfrm>
           <a:prstGeom prst="roundRect">
             <a:avLst>
@@ -4160,8 +4181,8 @@
         </p:nvSpPr>
         <p:spPr>
           <a:xfrm>
-            <a:off x="5330952" y="3429000"/>
-            <a:ext cx="715061" cy="274320"/>
+            <a:off x="5562108" y="3429000"/>
+            <a:ext cx="698157" cy="274320"/>
           </a:xfrm>
           <a:prstGeom prst="rect">
             <a:avLst/>
@@ -4199,8 +4220,8 @@
         </p:nvSpPr>
         <p:spPr>
           <a:xfrm>
-            <a:off x="6146597" y="3429000"/>
-            <a:ext cx="662026" cy="274320"/>
+            <a:off x="6360850" y="3429000"/>
+            <a:ext cx="648896" cy="274320"/>
           </a:xfrm>
           <a:prstGeom prst="roundRect">
             <a:avLst>
@@ -4226,8 +4247,8 @@
         </p:nvSpPr>
         <p:spPr>
           <a:xfrm>
-            <a:off x="6146597" y="3429000"/>
-            <a:ext cx="662026" cy="274320"/>
+            <a:off x="6360850" y="3429000"/>
+            <a:ext cx="648896" cy="274320"/>
           </a:xfrm>
           <a:prstGeom prst="rect">
             <a:avLst/>
@@ -4265,8 +4286,8 @@
         </p:nvSpPr>
         <p:spPr>
           <a:xfrm>
-            <a:off x="6909206" y="3429000"/>
-            <a:ext cx="1139342" cy="274320"/>
+            <a:off x="7110329" y="3429000"/>
+            <a:ext cx="1092251" cy="274320"/>
           </a:xfrm>
           <a:prstGeom prst="roundRect">
             <a:avLst>
@@ -4292,8 +4313,8 @@
         </p:nvSpPr>
         <p:spPr>
           <a:xfrm>
-            <a:off x="6909206" y="3429000"/>
-            <a:ext cx="1139342" cy="274320"/>
+            <a:off x="7110329" y="3429000"/>
+            <a:ext cx="1092251" cy="274320"/>
           </a:xfrm>
           <a:prstGeom prst="rect">
             <a:avLst/>
@@ -4331,8 +4352,8 @@
         </p:nvSpPr>
         <p:spPr>
           <a:xfrm>
-            <a:off x="8149133" y="3429000"/>
-            <a:ext cx="1033272" cy="274320"/>
+            <a:off x="8303164" y="3429000"/>
+            <a:ext cx="993727" cy="274320"/>
           </a:xfrm>
           <a:prstGeom prst="roundRect">
             <a:avLst>
@@ -4358,8 +4379,8 @@
         </p:nvSpPr>
         <p:spPr>
           <a:xfrm>
-            <a:off x="8149133" y="3429000"/>
-            <a:ext cx="1033272" cy="274320"/>
+            <a:off x="8303164" y="3429000"/>
+            <a:ext cx="993727" cy="274320"/>
           </a:xfrm>
           <a:prstGeom prst="rect">
             <a:avLst/>
@@ -4397,8 +4418,8 @@
         </p:nvSpPr>
         <p:spPr>
           <a:xfrm>
-            <a:off x="9282989" y="3429000"/>
-            <a:ext cx="768096" cy="274320"/>
+            <a:off x="9397476" y="3429000"/>
+            <a:ext cx="747419" cy="274320"/>
           </a:xfrm>
           <a:prstGeom prst="roundRect">
             <a:avLst>
@@ -4424,8 +4445,8 @@
         </p:nvSpPr>
         <p:spPr>
           <a:xfrm>
-            <a:off x="9282989" y="3429000"/>
-            <a:ext cx="768096" cy="274320"/>
+            <a:off x="9397476" y="3429000"/>
+            <a:ext cx="747419" cy="274320"/>
           </a:xfrm>
           <a:prstGeom prst="rect">
             <a:avLst/>
@@ -4463,8 +4484,8 @@
         </p:nvSpPr>
         <p:spPr>
           <a:xfrm>
-            <a:off x="10151669" y="3429000"/>
-            <a:ext cx="555955" cy="274320"/>
+            <a:off x="10245479" y="3429000"/>
+            <a:ext cx="550372" cy="274320"/>
           </a:xfrm>
           <a:prstGeom prst="roundRect">
             <a:avLst>
@@ -4490,8 +4511,8 @@
         </p:nvSpPr>
         <p:spPr>
           <a:xfrm>
-            <a:off x="10151669" y="3429000"/>
-            <a:ext cx="555955" cy="274320"/>
+            <a:off x="10245479" y="3429000"/>
+            <a:ext cx="550372" cy="274320"/>
           </a:xfrm>
           <a:prstGeom prst="rect">
             <a:avLst/>
@@ -4529,8 +4550,8 @@
         </p:nvSpPr>
         <p:spPr>
           <a:xfrm>
-            <a:off x="10808208" y="3429000"/>
-            <a:ext cx="715061" cy="274320"/>
+            <a:off x="10896435" y="3429000"/>
+            <a:ext cx="698157" cy="274320"/>
           </a:xfrm>
           <a:prstGeom prst="roundRect">
             <a:avLst>
@@ -4556,8 +4577,8 @@
         </p:nvSpPr>
         <p:spPr>
           <a:xfrm>
-            <a:off x="10808208" y="3429000"/>
-            <a:ext cx="715061" cy="274320"/>
+            <a:off x="10896435" y="3429000"/>
+            <a:ext cx="698157" cy="274320"/>
           </a:xfrm>
           <a:prstGeom prst="rect">
             <a:avLst/>
@@ -4595,8 +4616,8 @@
         </p:nvSpPr>
         <p:spPr>
           <a:xfrm>
-            <a:off x="2990088" y="3776472"/>
-            <a:ext cx="8348472" cy="219456"/>
+            <a:off x="3264408" y="3776472"/>
+            <a:ext cx="8074152" cy="219456"/>
           </a:xfrm>
           <a:prstGeom prst="rect">
             <a:avLst/>
@@ -4614,7 +4635,7 @@
             <a:r>
               <a:rPr lang="en-US" sz="880" dirty="0">
                 <a:solidFill>
-                  <a:srgbClr val="B9CDDD"/>
+                  <a:srgbClr val="43566B"/>
                 </a:solidFill>
                 <a:latin typeface="Calibri" pitchFamily="34" charset="0"/>
                 <a:ea typeface="Calibri" pitchFamily="34" charset="-122"/>
@@ -4643,7 +4664,7 @@
           <a:noFill/>
           <a:ln w="17780">
             <a:solidFill>
-              <a:srgbClr val="4E7CA6"/>
+              <a:srgbClr val="64798F"/>
             </a:solidFill>
             <a:prstDash val="solid"/>
             <a:headEnd type="none"/>
@@ -4664,18 +4685,25 @@
           </a:xfrm>
           <a:prstGeom prst="roundRect">
             <a:avLst>
-              <a:gd name="adj" fmla="val 4878"/>
+              <a:gd name="adj" fmla="val 12195"/>
             </a:avLst>
           </a:prstGeom>
           <a:solidFill>
-            <a:srgbClr val="1E3F5E"/>
+            <a:srgbClr val="F8FAFC"/>
           </a:solidFill>
-          <a:ln w="12700">
-            <a:solidFill>
-              <a:srgbClr val="2F5A80"/>
+          <a:ln w="15875">
+            <a:solidFill>
+              <a:srgbClr val="A6DDE4"/>
             </a:solidFill>
             <a:prstDash val="solid"/>
           </a:ln>
+          <a:effectLst>
+            <a:outerShdw sx="100000" sy="100000" kx="0" ky="0" algn="bl" rotWithShape="0" blurRad="101600" dist="19050" dir="5400000">
+              <a:srgbClr val="9FB0C2">
+                <a:alpha val="24000"/>
+              </a:srgbClr>
+            </a:outerShdw>
+          </a:effectLst>
         </p:spPr>
       </p:sp>
       <p:sp>
@@ -4695,7 +4723,7 @@
             </a:avLst>
           </a:prstGeom>
           <a:solidFill>
-            <a:srgbClr val="2C5B85"/>
+            <a:srgbClr val="108494"/>
           </a:solidFill>
           <a:ln/>
         </p:spPr>
@@ -4733,7 +4761,7 @@
         <p:spPr>
           <a:xfrm>
             <a:off x="1344168" y="4357116"/>
-            <a:ext cx="1600200" cy="237744"/>
+            <a:ext cx="1874520" cy="237744"/>
           </a:xfrm>
           <a:prstGeom prst="rect">
             <a:avLst/>
@@ -4751,7 +4779,7 @@
             <a:r>
               <a:rPr lang="en-US" sz="1250" b="1" dirty="0">
                 <a:solidFill>
-                  <a:srgbClr val="C9871B"/>
+                  <a:srgbClr val="0A4451"/>
                 </a:solidFill>
                 <a:latin typeface="Cambria" pitchFamily="34" charset="0"/>
                 <a:ea typeface="Cambria" pitchFamily="34" charset="-122"/>
@@ -4772,7 +4800,7 @@
         <p:spPr>
           <a:xfrm>
             <a:off x="1344168" y="4622292"/>
-            <a:ext cx="1600200" cy="201168"/>
+            <a:ext cx="1874520" cy="201168"/>
           </a:xfrm>
           <a:prstGeom prst="rect">
             <a:avLst/>
@@ -4790,7 +4818,7 @@
             <a:r>
               <a:rPr lang="en-US" sz="850" i="1" dirty="0">
                 <a:solidFill>
-                  <a:srgbClr val="B9CDDD"/>
+                  <a:srgbClr val="58697A"/>
                 </a:solidFill>
                 <a:latin typeface="Calibri" pitchFamily="34" charset="0"/>
                 <a:ea typeface="Calibri" pitchFamily="34" charset="-122"/>
@@ -4810,8 +4838,8 @@
         </p:nvSpPr>
         <p:spPr>
           <a:xfrm>
-            <a:off x="2990088" y="4347972"/>
-            <a:ext cx="768096" cy="274320"/>
+            <a:off x="3264408" y="4347972"/>
+            <a:ext cx="804672" cy="274320"/>
           </a:xfrm>
           <a:prstGeom prst="roundRect">
             <a:avLst>
@@ -4837,8 +4865,8 @@
         </p:nvSpPr>
         <p:spPr>
           <a:xfrm>
-            <a:off x="2990088" y="4347972"/>
-            <a:ext cx="768096" cy="274320"/>
+            <a:off x="3264408" y="4347972"/>
+            <a:ext cx="804672" cy="274320"/>
           </a:xfrm>
           <a:prstGeom prst="rect">
             <a:avLst/>
@@ -4876,8 +4904,8 @@
         </p:nvSpPr>
         <p:spPr>
           <a:xfrm>
-            <a:off x="3858768" y="4347972"/>
-            <a:ext cx="1139342" cy="274320"/>
+            <a:off x="4169664" y="4347972"/>
+            <a:ext cx="1175918" cy="274320"/>
           </a:xfrm>
           <a:prstGeom prst="roundRect">
             <a:avLst>
@@ -4903,8 +4931,8 @@
         </p:nvSpPr>
         <p:spPr>
           <a:xfrm>
-            <a:off x="3858768" y="4347972"/>
-            <a:ext cx="1139342" cy="274320"/>
+            <a:off x="4169664" y="4347972"/>
+            <a:ext cx="1175918" cy="274320"/>
           </a:xfrm>
           <a:prstGeom prst="rect">
             <a:avLst/>
@@ -4942,8 +4970,8 @@
         </p:nvSpPr>
         <p:spPr>
           <a:xfrm>
-            <a:off x="5098694" y="4347972"/>
-            <a:ext cx="1033272" cy="274320"/>
+            <a:off x="5446166" y="4347972"/>
+            <a:ext cx="1069848" cy="274320"/>
           </a:xfrm>
           <a:prstGeom prst="roundRect">
             <a:avLst>
@@ -4969,8 +4997,8 @@
         </p:nvSpPr>
         <p:spPr>
           <a:xfrm>
-            <a:off x="5098694" y="4347972"/>
-            <a:ext cx="1033272" cy="274320"/>
+            <a:off x="5446166" y="4347972"/>
+            <a:ext cx="1069848" cy="274320"/>
           </a:xfrm>
           <a:prstGeom prst="rect">
             <a:avLst/>
@@ -5008,8 +5036,8 @@
         </p:nvSpPr>
         <p:spPr>
           <a:xfrm>
-            <a:off x="6232550" y="4347972"/>
-            <a:ext cx="1192378" cy="274320"/>
+            <a:off x="6616598" y="4347972"/>
+            <a:ext cx="1228954" cy="274320"/>
           </a:xfrm>
           <a:prstGeom prst="roundRect">
             <a:avLst>
@@ -5035,8 +5063,8 @@
         </p:nvSpPr>
         <p:spPr>
           <a:xfrm>
-            <a:off x="6232550" y="4347972"/>
-            <a:ext cx="1192378" cy="274320"/>
+            <a:off x="6616598" y="4347972"/>
+            <a:ext cx="1228954" cy="274320"/>
           </a:xfrm>
           <a:prstGeom prst="rect">
             <a:avLst/>
@@ -5074,8 +5102,8 @@
         </p:nvSpPr>
         <p:spPr>
           <a:xfrm>
-            <a:off x="2990088" y="4695444"/>
-            <a:ext cx="8348472" cy="219456"/>
+            <a:off x="3264408" y="4695444"/>
+            <a:ext cx="8074152" cy="219456"/>
           </a:xfrm>
           <a:prstGeom prst="rect">
             <a:avLst/>
@@ -5093,7 +5121,7 @@
             <a:r>
               <a:rPr lang="en-US" sz="880" dirty="0">
                 <a:solidFill>
-                  <a:srgbClr val="B9CDDD"/>
+                  <a:srgbClr val="43566B"/>
                 </a:solidFill>
                 <a:latin typeface="Calibri" pitchFamily="34" charset="0"/>
                 <a:ea typeface="Calibri" pitchFamily="34" charset="-122"/>
@@ -5122,7 +5150,7 @@
           <a:noFill/>
           <a:ln w="17780">
             <a:solidFill>
-              <a:srgbClr val="4E7CA6"/>
+              <a:srgbClr val="64798F"/>
             </a:solidFill>
             <a:prstDash val="solid"/>
             <a:headEnd type="none"/>
@@ -5143,18 +5171,25 @@
           </a:xfrm>
           <a:prstGeom prst="roundRect">
             <a:avLst>
-              <a:gd name="adj" fmla="val 4878"/>
+              <a:gd name="adj" fmla="val 12195"/>
             </a:avLst>
           </a:prstGeom>
           <a:solidFill>
-            <a:srgbClr val="1E3F5E"/>
+            <a:srgbClr val="F8FAFC"/>
           </a:solidFill>
-          <a:ln w="12700">
-            <a:solidFill>
-              <a:srgbClr val="2F5A80"/>
+          <a:ln w="15875">
+            <a:solidFill>
+              <a:srgbClr val="B2DEBB"/>
             </a:solidFill>
             <a:prstDash val="solid"/>
           </a:ln>
+          <a:effectLst>
+            <a:outerShdw sx="100000" sy="100000" kx="0" ky="0" algn="bl" rotWithShape="0" blurRad="101600" dist="19050" dir="5400000">
+              <a:srgbClr val="9FB0C2">
+                <a:alpha val="24000"/>
+              </a:srgbClr>
+            </a:outerShdw>
+          </a:effectLst>
         </p:spPr>
       </p:sp>
       <p:sp>
@@ -5174,7 +5209,7 @@
             </a:avLst>
           </a:prstGeom>
           <a:solidFill>
-            <a:srgbClr val="2C5B85"/>
+            <a:srgbClr val="2F8F48"/>
           </a:solidFill>
           <a:ln/>
         </p:spPr>
@@ -5212,7 +5247,7 @@
         <p:spPr>
           <a:xfrm>
             <a:off x="1344168" y="5276088"/>
-            <a:ext cx="1600200" cy="237744"/>
+            <a:ext cx="1874520" cy="237744"/>
           </a:xfrm>
           <a:prstGeom prst="rect">
             <a:avLst/>
@@ -5230,7 +5265,7 @@
             <a:r>
               <a:rPr lang="en-US" sz="1250" b="1" dirty="0">
                 <a:solidFill>
-                  <a:srgbClr val="C9871B"/>
+                  <a:srgbClr val="17431F"/>
                 </a:solidFill>
                 <a:latin typeface="Cambria" pitchFamily="34" charset="0"/>
                 <a:ea typeface="Cambria" pitchFamily="34" charset="-122"/>
@@ -5251,7 +5286,7 @@
         <p:spPr>
           <a:xfrm>
             <a:off x="1344168" y="5541264"/>
-            <a:ext cx="1600200" cy="201168"/>
+            <a:ext cx="1874520" cy="201168"/>
           </a:xfrm>
           <a:prstGeom prst="rect">
             <a:avLst/>
@@ -5269,7 +5304,7 @@
             <a:r>
               <a:rPr lang="en-US" sz="850" i="1" dirty="0">
                 <a:solidFill>
-                  <a:srgbClr val="B9CDDD"/>
+                  <a:srgbClr val="58697A"/>
                 </a:solidFill>
                 <a:latin typeface="Calibri" pitchFamily="34" charset="0"/>
                 <a:ea typeface="Calibri" pitchFamily="34" charset="-122"/>
@@ -5289,8 +5324,8 @@
         </p:nvSpPr>
         <p:spPr>
           <a:xfrm>
-            <a:off x="2990088" y="5266944"/>
-            <a:ext cx="502920" cy="274320"/>
+            <a:off x="3264408" y="5266944"/>
+            <a:ext cx="539496" cy="274320"/>
           </a:xfrm>
           <a:prstGeom prst="roundRect">
             <a:avLst>
@@ -5316,8 +5351,8 @@
         </p:nvSpPr>
         <p:spPr>
           <a:xfrm>
-            <a:off x="2990088" y="5266944"/>
-            <a:ext cx="502920" cy="274320"/>
+            <a:off x="3264408" y="5266944"/>
+            <a:ext cx="539496" cy="274320"/>
           </a:xfrm>
           <a:prstGeom prst="rect">
             <a:avLst/>
@@ -5355,8 +5390,8 @@
         </p:nvSpPr>
         <p:spPr>
           <a:xfrm>
-            <a:off x="3593592" y="5266944"/>
-            <a:ext cx="821131" cy="274320"/>
+            <a:off x="3904488" y="5266944"/>
+            <a:ext cx="857707" cy="274320"/>
           </a:xfrm>
           <a:prstGeom prst="roundRect">
             <a:avLst>
@@ -5382,8 +5417,8 @@
         </p:nvSpPr>
         <p:spPr>
           <a:xfrm>
-            <a:off x="3593592" y="5266944"/>
-            <a:ext cx="821131" cy="274320"/>
+            <a:off x="3904488" y="5266944"/>
+            <a:ext cx="857707" cy="274320"/>
           </a:xfrm>
           <a:prstGeom prst="rect">
             <a:avLst/>
@@ -5421,8 +5456,8 @@
         </p:nvSpPr>
         <p:spPr>
           <a:xfrm>
-            <a:off x="4515307" y="5266944"/>
-            <a:ext cx="874166" cy="274320"/>
+            <a:off x="4862779" y="5266944"/>
+            <a:ext cx="910742" cy="274320"/>
           </a:xfrm>
           <a:prstGeom prst="roundRect">
             <a:avLst>
@@ -5448,8 +5483,8 @@
         </p:nvSpPr>
         <p:spPr>
           <a:xfrm>
-            <a:off x="4515307" y="5266944"/>
-            <a:ext cx="874166" cy="274320"/>
+            <a:off x="4862779" y="5266944"/>
+            <a:ext cx="910742" cy="274320"/>
           </a:xfrm>
           <a:prstGeom prst="rect">
             <a:avLst/>
@@ -5487,8 +5522,8 @@
         </p:nvSpPr>
         <p:spPr>
           <a:xfrm>
-            <a:off x="5490058" y="5266944"/>
-            <a:ext cx="662026" cy="274320"/>
+            <a:off x="5874106" y="5266944"/>
+            <a:ext cx="698602" cy="274320"/>
           </a:xfrm>
           <a:prstGeom prst="roundRect">
             <a:avLst>
@@ -5514,8 +5549,8 @@
         </p:nvSpPr>
         <p:spPr>
           <a:xfrm>
-            <a:off x="5490058" y="5266944"/>
-            <a:ext cx="662026" cy="274320"/>
+            <a:off x="5874106" y="5266944"/>
+            <a:ext cx="698602" cy="274320"/>
           </a:xfrm>
           <a:prstGeom prst="rect">
             <a:avLst/>
@@ -5553,8 +5588,8 @@
         </p:nvSpPr>
         <p:spPr>
           <a:xfrm>
-            <a:off x="6252667" y="5266944"/>
-            <a:ext cx="821131" cy="274320"/>
+            <a:off x="6673291" y="5266944"/>
+            <a:ext cx="857707" cy="274320"/>
           </a:xfrm>
           <a:prstGeom prst="roundRect">
             <a:avLst>
@@ -5580,8 +5615,8 @@
         </p:nvSpPr>
         <p:spPr>
           <a:xfrm>
-            <a:off x="6252667" y="5266944"/>
-            <a:ext cx="821131" cy="274320"/>
+            <a:off x="6673291" y="5266944"/>
+            <a:ext cx="857707" cy="274320"/>
           </a:xfrm>
           <a:prstGeom prst="rect">
             <a:avLst/>
@@ -5619,8 +5654,8 @@
         </p:nvSpPr>
         <p:spPr>
           <a:xfrm>
-            <a:off x="7174382" y="5266944"/>
-            <a:ext cx="1245413" cy="274320"/>
+            <a:off x="7631582" y="5266944"/>
+            <a:ext cx="1281989" cy="274320"/>
           </a:xfrm>
           <a:prstGeom prst="roundRect">
             <a:avLst>
@@ -5646,8 +5681,8 @@
         </p:nvSpPr>
         <p:spPr>
           <a:xfrm>
-            <a:off x="7174382" y="5266944"/>
-            <a:ext cx="1245413" cy="274320"/>
+            <a:off x="7631582" y="5266944"/>
+            <a:ext cx="1281989" cy="274320"/>
           </a:xfrm>
           <a:prstGeom prst="rect">
             <a:avLst/>
@@ -5685,8 +5720,8 @@
         </p:nvSpPr>
         <p:spPr>
           <a:xfrm>
-            <a:off x="2990088" y="5614416"/>
-            <a:ext cx="8348472" cy="219456"/>
+            <a:off x="3264408" y="5614416"/>
+            <a:ext cx="8074152" cy="219456"/>
           </a:xfrm>
           <a:prstGeom prst="rect">
             <a:avLst/>
@@ -5704,7 +5739,7 @@
             <a:r>
               <a:rPr lang="en-US" sz="880" dirty="0">
                 <a:solidFill>
-                  <a:srgbClr val="B9CDDD"/>
+                  <a:srgbClr val="43566B"/>
                 </a:solidFill>
                 <a:latin typeface="Calibri" pitchFamily="34" charset="0"/>
                 <a:ea typeface="Calibri" pitchFamily="34" charset="-122"/>
@@ -5724,7 +5759,7 @@
         </p:nvSpPr>
         <p:spPr>
           <a:xfrm>
-            <a:off x="594360" y="6199632"/>
+            <a:off x="594360" y="6172200"/>
             <a:ext cx="155448" cy="155448"/>
           </a:xfrm>
           <a:prstGeom prst="roundRect">
@@ -5746,7 +5781,7 @@
         </p:nvSpPr>
         <p:spPr>
           <a:xfrm>
-            <a:off x="813816" y="6172200"/>
+            <a:off x="813816" y="6144768"/>
             <a:ext cx="1559052" cy="219456"/>
           </a:xfrm>
           <a:prstGeom prst="rect">
@@ -5765,7 +5800,7 @@
             <a:r>
               <a:rPr lang="en-US" sz="880" dirty="0">
                 <a:solidFill>
-                  <a:srgbClr val="B9CDDD"/>
+                  <a:srgbClr val="58697A"/>
                 </a:solidFill>
                 <a:latin typeface="Calibri" pitchFamily="34" charset="0"/>
                 <a:ea typeface="Calibri" pitchFamily="34" charset="-122"/>
@@ -5785,7 +5820,7 @@
         </p:nvSpPr>
         <p:spPr>
           <a:xfrm>
-            <a:off x="2427732" y="6199632"/>
+            <a:off x="2427732" y="6172200"/>
             <a:ext cx="155448" cy="155448"/>
           </a:xfrm>
           <a:prstGeom prst="roundRect">
@@ -5807,7 +5842,7 @@
         </p:nvSpPr>
         <p:spPr>
           <a:xfrm>
-            <a:off x="2647188" y="6172200"/>
+            <a:off x="2647188" y="6144768"/>
             <a:ext cx="1559052" cy="219456"/>
           </a:xfrm>
           <a:prstGeom prst="rect">
@@ -5826,7 +5861,7 @@
             <a:r>
               <a:rPr lang="en-US" sz="880" dirty="0">
                 <a:solidFill>
-                  <a:srgbClr val="B9CDDD"/>
+                  <a:srgbClr val="58697A"/>
                 </a:solidFill>
                 <a:latin typeface="Calibri" pitchFamily="34" charset="0"/>
                 <a:ea typeface="Calibri" pitchFamily="34" charset="-122"/>
@@ -5846,7 +5881,7 @@
         </p:nvSpPr>
         <p:spPr>
           <a:xfrm>
-            <a:off x="4261104" y="6199632"/>
+            <a:off x="4261104" y="6172200"/>
             <a:ext cx="155448" cy="155448"/>
           </a:xfrm>
           <a:prstGeom prst="roundRect">
@@ -5868,7 +5903,7 @@
         </p:nvSpPr>
         <p:spPr>
           <a:xfrm>
-            <a:off x="4480560" y="6172200"/>
+            <a:off x="4480560" y="6144768"/>
             <a:ext cx="1559052" cy="219456"/>
           </a:xfrm>
           <a:prstGeom prst="rect">
@@ -5887,7 +5922,7 @@
             <a:r>
               <a:rPr lang="en-US" sz="880" dirty="0">
                 <a:solidFill>
-                  <a:srgbClr val="B9CDDD"/>
+                  <a:srgbClr val="58697A"/>
                 </a:solidFill>
                 <a:latin typeface="Calibri" pitchFamily="34" charset="0"/>
                 <a:ea typeface="Calibri" pitchFamily="34" charset="-122"/>
@@ -5907,7 +5942,7 @@
         </p:nvSpPr>
         <p:spPr>
           <a:xfrm>
-            <a:off x="6094476" y="6199632"/>
+            <a:off x="6094476" y="6172200"/>
             <a:ext cx="155448" cy="155448"/>
           </a:xfrm>
           <a:prstGeom prst="roundRect">
@@ -5929,7 +5964,7 @@
         </p:nvSpPr>
         <p:spPr>
           <a:xfrm>
-            <a:off x="6313932" y="6172200"/>
+            <a:off x="6313932" y="6144768"/>
             <a:ext cx="1559052" cy="219456"/>
           </a:xfrm>
           <a:prstGeom prst="rect">
@@ -5948,7 +5983,7 @@
             <a:r>
               <a:rPr lang="en-US" sz="880" dirty="0">
                 <a:solidFill>
-                  <a:srgbClr val="B9CDDD"/>
+                  <a:srgbClr val="58697A"/>
                 </a:solidFill>
                 <a:latin typeface="Calibri" pitchFamily="34" charset="0"/>
                 <a:ea typeface="Calibri" pitchFamily="34" charset="-122"/>
@@ -5968,7 +6003,7 @@
         </p:nvSpPr>
         <p:spPr>
           <a:xfrm>
-            <a:off x="7927848" y="6199632"/>
+            <a:off x="7927848" y="6172200"/>
             <a:ext cx="155448" cy="155448"/>
           </a:xfrm>
           <a:prstGeom prst="roundRect">
@@ -5990,7 +6025,7 @@
         </p:nvSpPr>
         <p:spPr>
           <a:xfrm>
-            <a:off x="8147304" y="6172200"/>
+            <a:off x="8147304" y="6144768"/>
             <a:ext cx="1559052" cy="219456"/>
           </a:xfrm>
           <a:prstGeom prst="rect">
@@ -6009,7 +6044,7 @@
             <a:r>
               <a:rPr lang="en-US" sz="880" dirty="0">
                 <a:solidFill>
-                  <a:srgbClr val="B9CDDD"/>
+                  <a:srgbClr val="58697A"/>
                 </a:solidFill>
                 <a:latin typeface="Calibri" pitchFamily="34" charset="0"/>
                 <a:ea typeface="Calibri" pitchFamily="34" charset="-122"/>
@@ -6029,7 +6064,7 @@
         </p:nvSpPr>
         <p:spPr>
           <a:xfrm>
-            <a:off x="9761220" y="6199632"/>
+            <a:off x="9761220" y="6172200"/>
             <a:ext cx="155448" cy="155448"/>
           </a:xfrm>
           <a:prstGeom prst="roundRect">
@@ -6051,7 +6086,7 @@
         </p:nvSpPr>
         <p:spPr>
           <a:xfrm>
-            <a:off x="9980676" y="6172200"/>
+            <a:off x="9980676" y="6144768"/>
             <a:ext cx="1559052" cy="219456"/>
           </a:xfrm>
           <a:prstGeom prst="rect">
@@ -6070,7 +6105,7 @@
             <a:r>
               <a:rPr lang="en-US" sz="880" dirty="0">
                 <a:solidFill>
-                  <a:srgbClr val="B9CDDD"/>
+                  <a:srgbClr val="58697A"/>
                 </a:solidFill>
                 <a:latin typeface="Calibri" pitchFamily="34" charset="0"/>
                 <a:ea typeface="Calibri" pitchFamily="34" charset="-122"/>

</xml_diff>

<commit_message>
Give every slide in the ARP deck a white background
The cover and section dividers move from navy to white with dark text;
content slides move from light slate to white.

Co-Authored-By: Claude Opus 5.5 <noreply@anthropic.com>
Claude-Session: https://claude.ai/code/session_018uBeEXxZxYzjxdTwWMkrm7
</commit_message>
<xml_diff>
--- a/docs/decks/arp-functions-and-architecture.pptx
+++ b/docs/decks/arp-functions-and-architecture.pptx
@@ -5774,7 +5774,7 @@
     <p:bg>
       <p:bgPr>
         <a:solidFill>
-          <a:srgbClr val="0F172A"/>
+          <a:srgbClr val="FFFFFF"/>
         </a:solidFill>
         <a:effectLst/>
       </p:bgPr>
@@ -5819,7 +5819,7 @@
             <a:r>
               <a:rPr sz="1200" b="0">
                 <a:solidFill>
-                  <a:srgbClr val="22C55E"/>
+                  <a:srgbClr val="15803D"/>
                 </a:solidFill>
                 <a:latin typeface="IBM Plex Mono"/>
               </a:rPr>
@@ -5861,7 +5861,7 @@
             <a:r>
               <a:rPr sz="3600" b="1">
                 <a:solidFill>
-                  <a:srgbClr val="F8FAFC"/>
+                  <a:srgbClr val="0F172A"/>
                 </a:solidFill>
                 <a:latin typeface="IBM Plex Sans"/>
               </a:rPr>
@@ -5903,7 +5903,7 @@
             <a:r>
               <a:rPr sz="1200" b="0">
                 <a:solidFill>
-                  <a:srgbClr val="94A3B8"/>
+                  <a:srgbClr val="475569"/>
                 </a:solidFill>
                 <a:latin typeface="IBM Plex Mono"/>
               </a:rPr>
@@ -5929,11 +5929,11 @@
             </a:avLst>
           </a:prstGeom>
           <a:solidFill>
-            <a:srgbClr val="1E293B"/>
+            <a:srgbClr val="FFFFFF"/>
           </a:solidFill>
           <a:ln w="9525">
             <a:solidFill>
-              <a:srgbClr val="334155"/>
+              <a:srgbClr val="E2E8F0"/>
             </a:solidFill>
           </a:ln>
           <a:effectLst/>
@@ -5961,7 +5961,7 @@
             <a:avLst/>
           </a:prstGeom>
           <a:solidFill>
-            <a:srgbClr val="334155"/>
+            <a:srgbClr val="0F172A"/>
           </a:solidFill>
           <a:ln>
             <a:noFill/>
@@ -6033,7 +6033,7 @@
             <a:r>
               <a:rPr sz="1500" b="1">
                 <a:solidFill>
-                  <a:srgbClr val="F8FAFC"/>
+                  <a:srgbClr val="0F172A"/>
                 </a:solidFill>
                 <a:latin typeface="IBM Plex Sans"/>
               </a:rPr>
@@ -6075,7 +6075,7 @@
             <a:r>
               <a:rPr sz="1200" b="0">
                 <a:solidFill>
-                  <a:srgbClr val="94A3B8"/>
+                  <a:srgbClr val="475569"/>
                 </a:solidFill>
                 <a:latin typeface="IBM Plex Sans"/>
               </a:rPr>
@@ -6101,11 +6101,11 @@
             </a:avLst>
           </a:prstGeom>
           <a:solidFill>
-            <a:srgbClr val="1E293B"/>
+            <a:srgbClr val="FFFFFF"/>
           </a:solidFill>
           <a:ln w="9525">
             <a:solidFill>
-              <a:srgbClr val="334155"/>
+              <a:srgbClr val="E2E8F0"/>
             </a:solidFill>
           </a:ln>
           <a:effectLst/>
@@ -6133,7 +6133,7 @@
             <a:avLst/>
           </a:prstGeom>
           <a:solidFill>
-            <a:srgbClr val="334155"/>
+            <a:srgbClr val="0F172A"/>
           </a:solidFill>
           <a:ln>
             <a:noFill/>
@@ -6205,7 +6205,7 @@
             <a:r>
               <a:rPr sz="1500" b="1">
                 <a:solidFill>
-                  <a:srgbClr val="F8FAFC"/>
+                  <a:srgbClr val="0F172A"/>
                 </a:solidFill>
                 <a:latin typeface="IBM Plex Sans"/>
               </a:rPr>
@@ -6247,7 +6247,7 @@
             <a:r>
               <a:rPr sz="1200" b="0">
                 <a:solidFill>
-                  <a:srgbClr val="94A3B8"/>
+                  <a:srgbClr val="475569"/>
                 </a:solidFill>
                 <a:latin typeface="IBM Plex Sans"/>
               </a:rPr>
@@ -6289,7 +6289,7 @@
             <a:r>
               <a:rPr sz="1200" b="0">
                 <a:solidFill>
-                  <a:srgbClr val="94A3B8"/>
+                  <a:srgbClr val="475569"/>
                 </a:solidFill>
                 <a:latin typeface="IBM Plex Mono"/>
               </a:rPr>
@@ -6315,11 +6315,11 @@
             </a:avLst>
           </a:prstGeom>
           <a:solidFill>
-            <a:srgbClr val="1E293B"/>
+            <a:srgbClr val="FFFFFF"/>
           </a:solidFill>
           <a:ln w="9525">
             <a:solidFill>
-              <a:srgbClr val="334155"/>
+              <a:srgbClr val="E2E8F0"/>
             </a:solidFill>
           </a:ln>
           <a:effectLst/>
@@ -6419,7 +6419,7 @@
             <a:r>
               <a:rPr sz="1500" b="1">
                 <a:solidFill>
-                  <a:srgbClr val="F8FAFC"/>
+                  <a:srgbClr val="0F172A"/>
                 </a:solidFill>
                 <a:latin typeface="IBM Plex Sans"/>
               </a:rPr>
@@ -6461,7 +6461,7 @@
             <a:r>
               <a:rPr sz="1200" b="0">
                 <a:solidFill>
-                  <a:srgbClr val="94A3B8"/>
+                  <a:srgbClr val="475569"/>
                 </a:solidFill>
                 <a:latin typeface="IBM Plex Sans"/>
               </a:rPr>
@@ -6487,11 +6487,11 @@
             </a:avLst>
           </a:prstGeom>
           <a:solidFill>
-            <a:srgbClr val="1E293B"/>
+            <a:srgbClr val="FFFFFF"/>
           </a:solidFill>
           <a:ln w="9525">
             <a:solidFill>
-              <a:srgbClr val="334155"/>
+              <a:srgbClr val="E2E8F0"/>
             </a:solidFill>
           </a:ln>
           <a:effectLst/>
@@ -6591,7 +6591,7 @@
             <a:r>
               <a:rPr sz="1500" b="1">
                 <a:solidFill>
-                  <a:srgbClr val="F8FAFC"/>
+                  <a:srgbClr val="0F172A"/>
                 </a:solidFill>
                 <a:latin typeface="IBM Plex Sans"/>
               </a:rPr>
@@ -6633,7 +6633,7 @@
             <a:r>
               <a:rPr sz="1200" b="0">
                 <a:solidFill>
-                  <a:srgbClr val="94A3B8"/>
+                  <a:srgbClr val="475569"/>
                 </a:solidFill>
                 <a:latin typeface="IBM Plex Sans"/>
               </a:rPr>
@@ -6659,11 +6659,11 @@
             </a:avLst>
           </a:prstGeom>
           <a:solidFill>
-            <a:srgbClr val="1E293B"/>
+            <a:srgbClr val="FFFFFF"/>
           </a:solidFill>
           <a:ln w="9525">
             <a:solidFill>
-              <a:srgbClr val="334155"/>
+              <a:srgbClr val="E2E8F0"/>
             </a:solidFill>
           </a:ln>
           <a:effectLst/>
@@ -6763,7 +6763,7 @@
             <a:r>
               <a:rPr sz="1500" b="1">
                 <a:solidFill>
-                  <a:srgbClr val="F8FAFC"/>
+                  <a:srgbClr val="0F172A"/>
                 </a:solidFill>
                 <a:latin typeface="IBM Plex Sans"/>
               </a:rPr>
@@ -6805,7 +6805,7 @@
             <a:r>
               <a:rPr sz="1200" b="0">
                 <a:solidFill>
-                  <a:srgbClr val="94A3B8"/>
+                  <a:srgbClr val="475569"/>
                 </a:solidFill>
                 <a:latin typeface="IBM Plex Sans"/>
               </a:rPr>
@@ -6847,7 +6847,7 @@
             <a:r>
               <a:rPr sz="1200" b="0">
                 <a:solidFill>
-                  <a:srgbClr val="22C55E"/>
+                  <a:srgbClr val="15803D"/>
                 </a:solidFill>
                 <a:latin typeface="IBM Plex Mono"/>
               </a:rPr>
@@ -6889,7 +6889,7 @@
             <a:r>
               <a:rPr sz="1200" b="0">
                 <a:solidFill>
-                  <a:srgbClr val="94A3B8"/>
+                  <a:srgbClr val="475569"/>
                 </a:solidFill>
                 <a:latin typeface="IBM Plex Sans"/>
               </a:rPr>
@@ -6912,7 +6912,7 @@
     <p:bg>
       <p:bgPr>
         <a:solidFill>
-          <a:srgbClr val="F8FAFC"/>
+          <a:srgbClr val="FFFFFF"/>
         </a:solidFill>
         <a:effectLst/>
       </p:bgPr>
@@ -8958,7 +8958,7 @@
     <p:bg>
       <p:bgPr>
         <a:solidFill>
-          <a:srgbClr val="F8FAFC"/>
+          <a:srgbClr val="FFFFFF"/>
         </a:solidFill>
         <a:effectLst/>
       </p:bgPr>
@@ -11004,7 +11004,7 @@
     <p:bg>
       <p:bgPr>
         <a:solidFill>
-          <a:srgbClr val="F8FAFC"/>
+          <a:srgbClr val="FFFFFF"/>
         </a:solidFill>
         <a:effectLst/>
       </p:bgPr>
@@ -13050,7 +13050,7 @@
     <p:bg>
       <p:bgPr>
         <a:solidFill>
-          <a:srgbClr val="F8FAFC"/>
+          <a:srgbClr val="FFFFFF"/>
         </a:solidFill>
         <a:effectLst/>
       </p:bgPr>
@@ -15094,7 +15094,7 @@
     <p:bg>
       <p:bgPr>
         <a:solidFill>
-          <a:srgbClr val="F8FAFC"/>
+          <a:srgbClr val="FFFFFF"/>
         </a:solidFill>
         <a:effectLst/>
       </p:bgPr>
@@ -17140,7 +17140,7 @@
     <p:bg>
       <p:bgPr>
         <a:solidFill>
-          <a:srgbClr val="F8FAFC"/>
+          <a:srgbClr val="FFFFFF"/>
         </a:solidFill>
         <a:effectLst/>
       </p:bgPr>
@@ -19186,7 +19186,7 @@
     <p:bg>
       <p:bgPr>
         <a:solidFill>
-          <a:srgbClr val="F8FAFC"/>
+          <a:srgbClr val="FFFFFF"/>
         </a:solidFill>
         <a:effectLst/>
       </p:bgPr>
@@ -21232,7 +21232,7 @@
     <p:bg>
       <p:bgPr>
         <a:solidFill>
-          <a:srgbClr val="F8FAFC"/>
+          <a:srgbClr val="FFFFFF"/>
         </a:solidFill>
         <a:effectLst/>
       </p:bgPr>
@@ -23278,7 +23278,7 @@
     <p:bg>
       <p:bgPr>
         <a:solidFill>
-          <a:srgbClr val="F8FAFC"/>
+          <a:srgbClr val="FFFFFF"/>
         </a:solidFill>
         <a:effectLst/>
       </p:bgPr>
@@ -25324,7 +25324,7 @@
     <p:bg>
       <p:bgPr>
         <a:solidFill>
-          <a:srgbClr val="F8FAFC"/>
+          <a:srgbClr val="FFFFFF"/>
         </a:solidFill>
         <a:effectLst/>
       </p:bgPr>
@@ -27370,7 +27370,7 @@
     <p:bg>
       <p:bgPr>
         <a:solidFill>
-          <a:srgbClr val="F8FAFC"/>
+          <a:srgbClr val="FFFFFF"/>
         </a:solidFill>
         <a:effectLst/>
       </p:bgPr>
@@ -28940,7 +28940,7 @@
     <p:bg>
       <p:bgPr>
         <a:solidFill>
-          <a:srgbClr val="0F172A"/>
+          <a:srgbClr val="FFFFFF"/>
         </a:solidFill>
         <a:effectLst/>
       </p:bgPr>
@@ -28985,7 +28985,7 @@
             <a:r>
               <a:rPr sz="1200" b="0">
                 <a:solidFill>
-                  <a:srgbClr val="22C55E"/>
+                  <a:srgbClr val="15803D"/>
                 </a:solidFill>
                 <a:latin typeface="IBM Plex Mono"/>
               </a:rPr>
@@ -29027,7 +29027,7 @@
             <a:r>
               <a:rPr sz="5600" b="1">
                 <a:solidFill>
-                  <a:srgbClr val="F8FAFC"/>
+                  <a:srgbClr val="0F172A"/>
                 </a:solidFill>
                 <a:latin typeface="IBM Plex Sans"/>
               </a:rPr>
@@ -29069,7 +29069,7 @@
             <a:r>
               <a:rPr sz="1400" b="0">
                 <a:solidFill>
-                  <a:srgbClr val="94A3B8"/>
+                  <a:srgbClr val="475569"/>
                 </a:solidFill>
                 <a:latin typeface="IBM Plex Sans"/>
               </a:rPr>
@@ -29093,7 +29093,7 @@
             <a:avLst/>
           </a:prstGeom>
           <a:solidFill>
-            <a:srgbClr val="334155"/>
+            <a:srgbClr val="E2E8F0"/>
           </a:solidFill>
           <a:ln>
             <a:noFill/>
@@ -29141,7 +29141,7 @@
             <a:r>
               <a:rPr sz="1200" b="0">
                 <a:solidFill>
-                  <a:srgbClr val="22C55E"/>
+                  <a:srgbClr val="15803D"/>
                 </a:solidFill>
                 <a:latin typeface="IBM Plex Mono"/>
               </a:rPr>
@@ -29183,7 +29183,7 @@
             <a:r>
               <a:rPr sz="1400" b="1">
                 <a:solidFill>
-                  <a:srgbClr val="F8FAFC"/>
+                  <a:srgbClr val="0F172A"/>
                 </a:solidFill>
                 <a:latin typeface="IBM Plex Sans"/>
               </a:rPr>
@@ -29202,7 +29202,7 @@
             <a:r>
               <a:rPr sz="1200" b="0">
                 <a:solidFill>
-                  <a:srgbClr val="94A3B8"/>
+                  <a:srgbClr val="475569"/>
                 </a:solidFill>
                 <a:latin typeface="IBM Plex Sans"/>
               </a:rPr>
@@ -29226,7 +29226,7 @@
             <a:avLst/>
           </a:prstGeom>
           <a:solidFill>
-            <a:srgbClr val="334155"/>
+            <a:srgbClr val="E2E8F0"/>
           </a:solidFill>
           <a:ln>
             <a:noFill/>
@@ -29274,7 +29274,7 @@
             <a:r>
               <a:rPr sz="1200" b="0">
                 <a:solidFill>
-                  <a:srgbClr val="22C55E"/>
+                  <a:srgbClr val="15803D"/>
                 </a:solidFill>
                 <a:latin typeface="IBM Plex Mono"/>
               </a:rPr>
@@ -29316,7 +29316,7 @@
             <a:r>
               <a:rPr sz="1400" b="1">
                 <a:solidFill>
-                  <a:srgbClr val="F8FAFC"/>
+                  <a:srgbClr val="0F172A"/>
                 </a:solidFill>
                 <a:latin typeface="IBM Plex Sans"/>
               </a:rPr>
@@ -29335,7 +29335,7 @@
             <a:r>
               <a:rPr sz="1200" b="0">
                 <a:solidFill>
-                  <a:srgbClr val="94A3B8"/>
+                  <a:srgbClr val="475569"/>
                 </a:solidFill>
                 <a:latin typeface="IBM Plex Sans"/>
               </a:rPr>
@@ -29359,7 +29359,7 @@
             <a:avLst/>
           </a:prstGeom>
           <a:solidFill>
-            <a:srgbClr val="334155"/>
+            <a:srgbClr val="E2E8F0"/>
           </a:solidFill>
           <a:ln>
             <a:noFill/>
@@ -29407,7 +29407,7 @@
             <a:r>
               <a:rPr sz="1200" b="0">
                 <a:solidFill>
-                  <a:srgbClr val="22C55E"/>
+                  <a:srgbClr val="15803D"/>
                 </a:solidFill>
                 <a:latin typeface="IBM Plex Mono"/>
               </a:rPr>
@@ -29449,7 +29449,7 @@
             <a:r>
               <a:rPr sz="1400" b="1">
                 <a:solidFill>
-                  <a:srgbClr val="F8FAFC"/>
+                  <a:srgbClr val="0F172A"/>
                 </a:solidFill>
                 <a:latin typeface="IBM Plex Sans"/>
               </a:rPr>
@@ -29468,7 +29468,7 @@
             <a:r>
               <a:rPr sz="1200" b="0">
                 <a:solidFill>
-                  <a:srgbClr val="94A3B8"/>
+                  <a:srgbClr val="475569"/>
                 </a:solidFill>
                 <a:latin typeface="IBM Plex Sans"/>
               </a:rPr>
@@ -29492,7 +29492,7 @@
             <a:avLst/>
           </a:prstGeom>
           <a:solidFill>
-            <a:srgbClr val="334155"/>
+            <a:srgbClr val="E2E8F0"/>
           </a:solidFill>
           <a:ln>
             <a:noFill/>
@@ -29540,7 +29540,7 @@
             <a:r>
               <a:rPr sz="1200" b="0">
                 <a:solidFill>
-                  <a:srgbClr val="22C55E"/>
+                  <a:srgbClr val="15803D"/>
                 </a:solidFill>
                 <a:latin typeface="IBM Plex Mono"/>
               </a:rPr>
@@ -29582,7 +29582,7 @@
             <a:r>
               <a:rPr sz="1400" b="1">
                 <a:solidFill>
-                  <a:srgbClr val="F8FAFC"/>
+                  <a:srgbClr val="0F172A"/>
                 </a:solidFill>
                 <a:latin typeface="IBM Plex Sans"/>
               </a:rPr>
@@ -29601,7 +29601,7 @@
             <a:r>
               <a:rPr sz="1200" b="0">
                 <a:solidFill>
-                  <a:srgbClr val="94A3B8"/>
+                  <a:srgbClr val="475569"/>
                 </a:solidFill>
                 <a:latin typeface="IBM Plex Sans"/>
               </a:rPr>
@@ -29625,7 +29625,7 @@
             <a:avLst/>
           </a:prstGeom>
           <a:solidFill>
-            <a:srgbClr val="334155"/>
+            <a:srgbClr val="E2E8F0"/>
           </a:solidFill>
           <a:ln>
             <a:noFill/>
@@ -29673,7 +29673,7 @@
             <a:r>
               <a:rPr sz="1200" b="0">
                 <a:solidFill>
-                  <a:srgbClr val="22C55E"/>
+                  <a:srgbClr val="15803D"/>
                 </a:solidFill>
                 <a:latin typeface="IBM Plex Mono"/>
               </a:rPr>
@@ -29715,7 +29715,7 @@
             <a:r>
               <a:rPr sz="1400" b="1">
                 <a:solidFill>
-                  <a:srgbClr val="F8FAFC"/>
+                  <a:srgbClr val="0F172A"/>
                 </a:solidFill>
                 <a:latin typeface="IBM Plex Sans"/>
               </a:rPr>
@@ -29734,7 +29734,7 @@
             <a:r>
               <a:rPr sz="1200" b="0">
                 <a:solidFill>
-                  <a:srgbClr val="94A3B8"/>
+                  <a:srgbClr val="475569"/>
                 </a:solidFill>
                 <a:latin typeface="IBM Plex Sans"/>
               </a:rPr>
@@ -29758,7 +29758,7 @@
             <a:avLst/>
           </a:prstGeom>
           <a:solidFill>
-            <a:srgbClr val="334155"/>
+            <a:srgbClr val="E2E8F0"/>
           </a:solidFill>
           <a:ln>
             <a:noFill/>
@@ -29806,7 +29806,7 @@
             <a:r>
               <a:rPr sz="1200" b="0">
                 <a:solidFill>
-                  <a:srgbClr val="22C55E"/>
+                  <a:srgbClr val="15803D"/>
                 </a:solidFill>
                 <a:latin typeface="IBM Plex Mono"/>
               </a:rPr>
@@ -29848,7 +29848,7 @@
             <a:r>
               <a:rPr sz="1400" b="1">
                 <a:solidFill>
-                  <a:srgbClr val="F8FAFC"/>
+                  <a:srgbClr val="0F172A"/>
                 </a:solidFill>
                 <a:latin typeface="IBM Plex Sans"/>
               </a:rPr>
@@ -29867,7 +29867,7 @@
             <a:r>
               <a:rPr sz="1200" b="0">
                 <a:solidFill>
-                  <a:srgbClr val="94A3B8"/>
+                  <a:srgbClr val="475569"/>
                 </a:solidFill>
                 <a:latin typeface="IBM Plex Sans"/>
               </a:rPr>
@@ -29891,7 +29891,7 @@
             <a:avLst/>
           </a:prstGeom>
           <a:solidFill>
-            <a:srgbClr val="334155"/>
+            <a:srgbClr val="E2E8F0"/>
           </a:solidFill>
           <a:ln>
             <a:noFill/>
@@ -29939,7 +29939,7 @@
             <a:r>
               <a:rPr sz="1200" b="0">
                 <a:solidFill>
-                  <a:srgbClr val="22C55E"/>
+                  <a:srgbClr val="15803D"/>
                 </a:solidFill>
                 <a:latin typeface="IBM Plex Mono"/>
               </a:rPr>
@@ -29981,7 +29981,7 @@
             <a:r>
               <a:rPr sz="1400" b="1">
                 <a:solidFill>
-                  <a:srgbClr val="F8FAFC"/>
+                  <a:srgbClr val="0F172A"/>
                 </a:solidFill>
                 <a:latin typeface="IBM Plex Sans"/>
               </a:rPr>
@@ -30000,7 +30000,7 @@
             <a:r>
               <a:rPr sz="1200" b="0">
                 <a:solidFill>
-                  <a:srgbClr val="94A3B8"/>
+                  <a:srgbClr val="475569"/>
                 </a:solidFill>
                 <a:latin typeface="IBM Plex Sans"/>
               </a:rPr>
@@ -30024,7 +30024,7 @@
             <a:avLst/>
           </a:prstGeom>
           <a:solidFill>
-            <a:srgbClr val="334155"/>
+            <a:srgbClr val="E2E8F0"/>
           </a:solidFill>
           <a:ln>
             <a:noFill/>
@@ -30072,7 +30072,7 @@
             <a:r>
               <a:rPr sz="1200" b="0">
                 <a:solidFill>
-                  <a:srgbClr val="22C55E"/>
+                  <a:srgbClr val="15803D"/>
                 </a:solidFill>
                 <a:latin typeface="IBM Plex Mono"/>
               </a:rPr>
@@ -30114,7 +30114,7 @@
             <a:r>
               <a:rPr sz="1400" b="1">
                 <a:solidFill>
-                  <a:srgbClr val="F8FAFC"/>
+                  <a:srgbClr val="0F172A"/>
                 </a:solidFill>
                 <a:latin typeface="IBM Plex Sans"/>
               </a:rPr>
@@ -30133,7 +30133,7 @@
             <a:r>
               <a:rPr sz="1200" b="0">
                 <a:solidFill>
-                  <a:srgbClr val="94A3B8"/>
+                  <a:srgbClr val="475569"/>
                 </a:solidFill>
                 <a:latin typeface="IBM Plex Sans"/>
               </a:rPr>
@@ -30175,7 +30175,7 @@
             <a:r>
               <a:rPr sz="1200" b="0">
                 <a:solidFill>
-                  <a:srgbClr val="94A3B8"/>
+                  <a:srgbClr val="475569"/>
                 </a:solidFill>
                 <a:latin typeface="IBM Plex Mono"/>
               </a:rPr>
@@ -30217,7 +30217,7 @@
             <a:r>
               <a:rPr sz="1200" b="0">
                 <a:solidFill>
-                  <a:srgbClr val="94A3B8"/>
+                  <a:srgbClr val="475569"/>
                 </a:solidFill>
                 <a:latin typeface="IBM Plex Mono"/>
               </a:rPr>
@@ -30240,7 +30240,7 @@
     <p:bg>
       <p:bgPr>
         <a:solidFill>
-          <a:srgbClr val="F8FAFC"/>
+          <a:srgbClr val="FFFFFF"/>
         </a:solidFill>
         <a:effectLst/>
       </p:bgPr>
@@ -32286,7 +32286,7 @@
     <p:bg>
       <p:bgPr>
         <a:solidFill>
-          <a:srgbClr val="F8FAFC"/>
+          <a:srgbClr val="FFFFFF"/>
         </a:solidFill>
         <a:effectLst/>
       </p:bgPr>
@@ -34330,7 +34330,7 @@
     <p:bg>
       <p:bgPr>
         <a:solidFill>
-          <a:srgbClr val="F8FAFC"/>
+          <a:srgbClr val="FFFFFF"/>
         </a:solidFill>
         <a:effectLst/>
       </p:bgPr>
@@ -36376,7 +36376,7 @@
     <p:bg>
       <p:bgPr>
         <a:solidFill>
-          <a:srgbClr val="F8FAFC"/>
+          <a:srgbClr val="FFFFFF"/>
         </a:solidFill>
         <a:effectLst/>
       </p:bgPr>
@@ -38422,7 +38422,7 @@
     <p:bg>
       <p:bgPr>
         <a:solidFill>
-          <a:srgbClr val="F8FAFC"/>
+          <a:srgbClr val="FFFFFF"/>
         </a:solidFill>
         <a:effectLst/>
       </p:bgPr>
@@ -40468,7 +40468,7 @@
     <p:bg>
       <p:bgPr>
         <a:solidFill>
-          <a:srgbClr val="F8FAFC"/>
+          <a:srgbClr val="FFFFFF"/>
         </a:solidFill>
         <a:effectLst/>
       </p:bgPr>
@@ -42512,7 +42512,7 @@
     <p:bg>
       <p:bgPr>
         <a:solidFill>
-          <a:srgbClr val="F8FAFC"/>
+          <a:srgbClr val="FFFFFF"/>
         </a:solidFill>
         <a:effectLst/>
       </p:bgPr>
@@ -44558,7 +44558,7 @@
     <p:bg>
       <p:bgPr>
         <a:solidFill>
-          <a:srgbClr val="F8FAFC"/>
+          <a:srgbClr val="FFFFFF"/>
         </a:solidFill>
         <a:effectLst/>
       </p:bgPr>
@@ -46604,7 +46604,7 @@
     <p:bg>
       <p:bgPr>
         <a:solidFill>
-          <a:srgbClr val="F8FAFC"/>
+          <a:srgbClr val="FFFFFF"/>
         </a:solidFill>
         <a:effectLst/>
       </p:bgPr>
@@ -47929,7 +47929,7 @@
     <p:bg>
       <p:bgPr>
         <a:solidFill>
-          <a:srgbClr val="F8FAFC"/>
+          <a:srgbClr val="FFFFFF"/>
         </a:solidFill>
         <a:effectLst/>
       </p:bgPr>
@@ -48950,7 +48950,7 @@
     <p:bg>
       <p:bgPr>
         <a:solidFill>
-          <a:srgbClr val="F8FAFC"/>
+          <a:srgbClr val="FFFFFF"/>
         </a:solidFill>
         <a:effectLst/>
       </p:bgPr>
@@ -49971,7 +49971,7 @@
     <p:bg>
       <p:bgPr>
         <a:solidFill>
-          <a:srgbClr val="F8FAFC"/>
+          <a:srgbClr val="FFFFFF"/>
         </a:solidFill>
         <a:effectLst/>
       </p:bgPr>
@@ -50992,7 +50992,7 @@
     <p:bg>
       <p:bgPr>
         <a:solidFill>
-          <a:srgbClr val="F8FAFC"/>
+          <a:srgbClr val="FFFFFF"/>
         </a:solidFill>
         <a:effectLst/>
       </p:bgPr>
@@ -52013,7 +52013,7 @@
     <p:bg>
       <p:bgPr>
         <a:solidFill>
-          <a:srgbClr val="F8FAFC"/>
+          <a:srgbClr val="FFFFFF"/>
         </a:solidFill>
         <a:effectLst/>
       </p:bgPr>
@@ -53034,7 +53034,7 @@
     <p:bg>
       <p:bgPr>
         <a:solidFill>
-          <a:srgbClr val="F8FAFC"/>
+          <a:srgbClr val="FFFFFF"/>
         </a:solidFill>
         <a:effectLst/>
       </p:bgPr>
@@ -55791,7 +55791,7 @@
     <p:bg>
       <p:bgPr>
         <a:solidFill>
-          <a:srgbClr val="0F172A"/>
+          <a:srgbClr val="FFFFFF"/>
         </a:solidFill>
         <a:effectLst/>
       </p:bgPr>
@@ -55836,7 +55836,7 @@
             <a:r>
               <a:rPr sz="1200" b="0">
                 <a:solidFill>
-                  <a:srgbClr val="22C55E"/>
+                  <a:srgbClr val="15803D"/>
                 </a:solidFill>
                 <a:latin typeface="IBM Plex Mono"/>
               </a:rPr>
@@ -55878,7 +55878,7 @@
             <a:r>
               <a:rPr sz="5600" b="1">
                 <a:solidFill>
-                  <a:srgbClr val="F8FAFC"/>
+                  <a:srgbClr val="0F172A"/>
                 </a:solidFill>
                 <a:latin typeface="IBM Plex Sans"/>
               </a:rPr>
@@ -55920,7 +55920,7 @@
             <a:r>
               <a:rPr sz="1400" b="0">
                 <a:solidFill>
-                  <a:srgbClr val="94A3B8"/>
+                  <a:srgbClr val="475569"/>
                 </a:solidFill>
                 <a:latin typeface="IBM Plex Sans"/>
               </a:rPr>
@@ -55944,7 +55944,7 @@
             <a:avLst/>
           </a:prstGeom>
           <a:solidFill>
-            <a:srgbClr val="334155"/>
+            <a:srgbClr val="E2E8F0"/>
           </a:solidFill>
           <a:ln>
             <a:noFill/>
@@ -55992,7 +55992,7 @@
             <a:r>
               <a:rPr sz="1200" b="0">
                 <a:solidFill>
-                  <a:srgbClr val="22C55E"/>
+                  <a:srgbClr val="15803D"/>
                 </a:solidFill>
                 <a:latin typeface="IBM Plex Mono"/>
               </a:rPr>
@@ -56034,7 +56034,7 @@
             <a:r>
               <a:rPr sz="1400" b="1">
                 <a:solidFill>
-                  <a:srgbClr val="F8FAFC"/>
+                  <a:srgbClr val="0F172A"/>
                 </a:solidFill>
                 <a:latin typeface="IBM Plex Sans"/>
               </a:rPr>
@@ -56053,7 +56053,7 @@
             <a:r>
               <a:rPr sz="1200" b="0">
                 <a:solidFill>
-                  <a:srgbClr val="94A3B8"/>
+                  <a:srgbClr val="475569"/>
                 </a:solidFill>
                 <a:latin typeface="IBM Plex Sans"/>
               </a:rPr>
@@ -56077,7 +56077,7 @@
             <a:avLst/>
           </a:prstGeom>
           <a:solidFill>
-            <a:srgbClr val="334155"/>
+            <a:srgbClr val="E2E8F0"/>
           </a:solidFill>
           <a:ln>
             <a:noFill/>
@@ -56125,7 +56125,7 @@
             <a:r>
               <a:rPr sz="1200" b="0">
                 <a:solidFill>
-                  <a:srgbClr val="22C55E"/>
+                  <a:srgbClr val="15803D"/>
                 </a:solidFill>
                 <a:latin typeface="IBM Plex Mono"/>
               </a:rPr>
@@ -56167,7 +56167,7 @@
             <a:r>
               <a:rPr sz="1400" b="1">
                 <a:solidFill>
-                  <a:srgbClr val="F8FAFC"/>
+                  <a:srgbClr val="0F172A"/>
                 </a:solidFill>
                 <a:latin typeface="IBM Plex Sans"/>
               </a:rPr>
@@ -56186,7 +56186,7 @@
             <a:r>
               <a:rPr sz="1200" b="0">
                 <a:solidFill>
-                  <a:srgbClr val="94A3B8"/>
+                  <a:srgbClr val="475569"/>
                 </a:solidFill>
                 <a:latin typeface="IBM Plex Sans"/>
               </a:rPr>
@@ -56210,7 +56210,7 @@
             <a:avLst/>
           </a:prstGeom>
           <a:solidFill>
-            <a:srgbClr val="334155"/>
+            <a:srgbClr val="E2E8F0"/>
           </a:solidFill>
           <a:ln>
             <a:noFill/>
@@ -56258,7 +56258,7 @@
             <a:r>
               <a:rPr sz="1200" b="0">
                 <a:solidFill>
-                  <a:srgbClr val="22C55E"/>
+                  <a:srgbClr val="15803D"/>
                 </a:solidFill>
                 <a:latin typeface="IBM Plex Mono"/>
               </a:rPr>
@@ -56300,7 +56300,7 @@
             <a:r>
               <a:rPr sz="1400" b="1">
                 <a:solidFill>
-                  <a:srgbClr val="F8FAFC"/>
+                  <a:srgbClr val="0F172A"/>
                 </a:solidFill>
                 <a:latin typeface="IBM Plex Sans"/>
               </a:rPr>
@@ -56319,7 +56319,7 @@
             <a:r>
               <a:rPr sz="1200" b="0">
                 <a:solidFill>
-                  <a:srgbClr val="94A3B8"/>
+                  <a:srgbClr val="475569"/>
                 </a:solidFill>
                 <a:latin typeface="IBM Plex Sans"/>
               </a:rPr>
@@ -56343,7 +56343,7 @@
             <a:avLst/>
           </a:prstGeom>
           <a:solidFill>
-            <a:srgbClr val="334155"/>
+            <a:srgbClr val="E2E8F0"/>
           </a:solidFill>
           <a:ln>
             <a:noFill/>
@@ -56391,7 +56391,7 @@
             <a:r>
               <a:rPr sz="1200" b="0">
                 <a:solidFill>
-                  <a:srgbClr val="22C55E"/>
+                  <a:srgbClr val="15803D"/>
                 </a:solidFill>
                 <a:latin typeface="IBM Plex Mono"/>
               </a:rPr>
@@ -56433,7 +56433,7 @@
             <a:r>
               <a:rPr sz="1400" b="1">
                 <a:solidFill>
-                  <a:srgbClr val="F8FAFC"/>
+                  <a:srgbClr val="0F172A"/>
                 </a:solidFill>
                 <a:latin typeface="IBM Plex Sans"/>
               </a:rPr>
@@ -56452,7 +56452,7 @@
             <a:r>
               <a:rPr sz="1200" b="0">
                 <a:solidFill>
-                  <a:srgbClr val="94A3B8"/>
+                  <a:srgbClr val="475569"/>
                 </a:solidFill>
                 <a:latin typeface="IBM Plex Sans"/>
               </a:rPr>
@@ -56476,7 +56476,7 @@
             <a:avLst/>
           </a:prstGeom>
           <a:solidFill>
-            <a:srgbClr val="334155"/>
+            <a:srgbClr val="E2E8F0"/>
           </a:solidFill>
           <a:ln>
             <a:noFill/>
@@ -56524,7 +56524,7 @@
             <a:r>
               <a:rPr sz="1200" b="0">
                 <a:solidFill>
-                  <a:srgbClr val="22C55E"/>
+                  <a:srgbClr val="15803D"/>
                 </a:solidFill>
                 <a:latin typeface="IBM Plex Mono"/>
               </a:rPr>
@@ -56566,7 +56566,7 @@
             <a:r>
               <a:rPr sz="1400" b="1">
                 <a:solidFill>
-                  <a:srgbClr val="F8FAFC"/>
+                  <a:srgbClr val="0F172A"/>
                 </a:solidFill>
                 <a:latin typeface="IBM Plex Sans"/>
               </a:rPr>
@@ -56585,7 +56585,7 @@
             <a:r>
               <a:rPr sz="1200" b="0">
                 <a:solidFill>
-                  <a:srgbClr val="94A3B8"/>
+                  <a:srgbClr val="475569"/>
                 </a:solidFill>
                 <a:latin typeface="IBM Plex Sans"/>
               </a:rPr>
@@ -56609,7 +56609,7 @@
             <a:avLst/>
           </a:prstGeom>
           <a:solidFill>
-            <a:srgbClr val="334155"/>
+            <a:srgbClr val="E2E8F0"/>
           </a:solidFill>
           <a:ln>
             <a:noFill/>
@@ -56657,7 +56657,7 @@
             <a:r>
               <a:rPr sz="1200" b="0">
                 <a:solidFill>
-                  <a:srgbClr val="22C55E"/>
+                  <a:srgbClr val="15803D"/>
                 </a:solidFill>
                 <a:latin typeface="IBM Plex Mono"/>
               </a:rPr>
@@ -56699,7 +56699,7 @@
             <a:r>
               <a:rPr sz="1400" b="1">
                 <a:solidFill>
-                  <a:srgbClr val="F8FAFC"/>
+                  <a:srgbClr val="0F172A"/>
                 </a:solidFill>
                 <a:latin typeface="IBM Plex Sans"/>
               </a:rPr>
@@ -56718,7 +56718,7 @@
             <a:r>
               <a:rPr sz="1200" b="0">
                 <a:solidFill>
-                  <a:srgbClr val="94A3B8"/>
+                  <a:srgbClr val="475569"/>
                 </a:solidFill>
                 <a:latin typeface="IBM Plex Sans"/>
               </a:rPr>
@@ -56742,7 +56742,7 @@
             <a:avLst/>
           </a:prstGeom>
           <a:solidFill>
-            <a:srgbClr val="334155"/>
+            <a:srgbClr val="E2E8F0"/>
           </a:solidFill>
           <a:ln>
             <a:noFill/>
@@ -56790,7 +56790,7 @@
             <a:r>
               <a:rPr sz="1200" b="0">
                 <a:solidFill>
-                  <a:srgbClr val="22C55E"/>
+                  <a:srgbClr val="15803D"/>
                 </a:solidFill>
                 <a:latin typeface="IBM Plex Mono"/>
               </a:rPr>
@@ -56832,7 +56832,7 @@
             <a:r>
               <a:rPr sz="1400" b="1">
                 <a:solidFill>
-                  <a:srgbClr val="F8FAFC"/>
+                  <a:srgbClr val="0F172A"/>
                 </a:solidFill>
                 <a:latin typeface="IBM Plex Sans"/>
               </a:rPr>
@@ -56851,7 +56851,7 @@
             <a:r>
               <a:rPr sz="1200" b="0">
                 <a:solidFill>
-                  <a:srgbClr val="94A3B8"/>
+                  <a:srgbClr val="475569"/>
                 </a:solidFill>
                 <a:latin typeface="IBM Plex Sans"/>
               </a:rPr>
@@ -56875,7 +56875,7 @@
             <a:avLst/>
           </a:prstGeom>
           <a:solidFill>
-            <a:srgbClr val="334155"/>
+            <a:srgbClr val="E2E8F0"/>
           </a:solidFill>
           <a:ln>
             <a:noFill/>
@@ -56923,7 +56923,7 @@
             <a:r>
               <a:rPr sz="1200" b="0">
                 <a:solidFill>
-                  <a:srgbClr val="22C55E"/>
+                  <a:srgbClr val="15803D"/>
                 </a:solidFill>
                 <a:latin typeface="IBM Plex Mono"/>
               </a:rPr>
@@ -56965,7 +56965,7 @@
             <a:r>
               <a:rPr sz="1400" b="1">
                 <a:solidFill>
-                  <a:srgbClr val="F8FAFC"/>
+                  <a:srgbClr val="0F172A"/>
                 </a:solidFill>
                 <a:latin typeface="IBM Plex Sans"/>
               </a:rPr>
@@ -56984,7 +56984,7 @@
             <a:r>
               <a:rPr sz="1200" b="0">
                 <a:solidFill>
-                  <a:srgbClr val="94A3B8"/>
+                  <a:srgbClr val="475569"/>
                 </a:solidFill>
                 <a:latin typeface="IBM Plex Sans"/>
               </a:rPr>
@@ -57008,7 +57008,7 @@
             <a:avLst/>
           </a:prstGeom>
           <a:solidFill>
-            <a:srgbClr val="334155"/>
+            <a:srgbClr val="E2E8F0"/>
           </a:solidFill>
           <a:ln>
             <a:noFill/>
@@ -57056,7 +57056,7 @@
             <a:r>
               <a:rPr sz="1200" b="0">
                 <a:solidFill>
-                  <a:srgbClr val="22C55E"/>
+                  <a:srgbClr val="15803D"/>
                 </a:solidFill>
                 <a:latin typeface="IBM Plex Mono"/>
               </a:rPr>
@@ -57098,7 +57098,7 @@
             <a:r>
               <a:rPr sz="1400" b="1">
                 <a:solidFill>
-                  <a:srgbClr val="F8FAFC"/>
+                  <a:srgbClr val="0F172A"/>
                 </a:solidFill>
                 <a:latin typeface="IBM Plex Sans"/>
               </a:rPr>
@@ -57117,7 +57117,7 @@
             <a:r>
               <a:rPr sz="1200" b="0">
                 <a:solidFill>
-                  <a:srgbClr val="94A3B8"/>
+                  <a:srgbClr val="475569"/>
                 </a:solidFill>
                 <a:latin typeface="IBM Plex Sans"/>
               </a:rPr>
@@ -57141,7 +57141,7 @@
             <a:avLst/>
           </a:prstGeom>
           <a:solidFill>
-            <a:srgbClr val="334155"/>
+            <a:srgbClr val="E2E8F0"/>
           </a:solidFill>
           <a:ln>
             <a:noFill/>
@@ -57189,7 +57189,7 @@
             <a:r>
               <a:rPr sz="1200" b="0">
                 <a:solidFill>
-                  <a:srgbClr val="22C55E"/>
+                  <a:srgbClr val="15803D"/>
                 </a:solidFill>
                 <a:latin typeface="IBM Plex Mono"/>
               </a:rPr>
@@ -57231,7 +57231,7 @@
             <a:r>
               <a:rPr sz="1400" b="1">
                 <a:solidFill>
-                  <a:srgbClr val="F8FAFC"/>
+                  <a:srgbClr val="0F172A"/>
                 </a:solidFill>
                 <a:latin typeface="IBM Plex Sans"/>
               </a:rPr>
@@ -57250,7 +57250,7 @@
             <a:r>
               <a:rPr sz="1200" b="0">
                 <a:solidFill>
-                  <a:srgbClr val="94A3B8"/>
+                  <a:srgbClr val="475569"/>
                 </a:solidFill>
                 <a:latin typeface="IBM Plex Sans"/>
               </a:rPr>
@@ -57292,7 +57292,7 @@
             <a:r>
               <a:rPr sz="1200" b="0">
                 <a:solidFill>
-                  <a:srgbClr val="94A3B8"/>
+                  <a:srgbClr val="475569"/>
                 </a:solidFill>
                 <a:latin typeface="IBM Plex Mono"/>
               </a:rPr>
@@ -57334,7 +57334,7 @@
             <a:r>
               <a:rPr sz="1200" b="0">
                 <a:solidFill>
-                  <a:srgbClr val="94A3B8"/>
+                  <a:srgbClr val="475569"/>
                 </a:solidFill>
                 <a:latin typeface="IBM Plex Mono"/>
               </a:rPr>

</xml_diff>

<commit_message>
Show a green capex extraction on the ARP deck's review slide
Replaces the Apple 10-K example with a live run of the green capex
preset on Signify's 2025 ESEF annual report: EUR 101.4m of EUR 230.5m
capex EU Taxonomy-aligned, grounded on page 25, with the prior-period
jump check flagging it for review.

Co-Authored-By: Claude Opus 5.5 <noreply@anthropic.com>
Claude-Session: https://claude.ai/code/session_018uBeEXxZxYzjxdTwWMkrm7
</commit_message>
<xml_diff>
--- a/docs/decks/arp-functions-and-architecture.pptx
+++ b/docs/decks/arp-functions-and-architecture.pptx
@@ -3495,7 +3495,7 @@
           <a:lstStyle/>
           <a:p>
             <a:r>
-              <a:t>A real run, made for this deck on 26 October 2026: one company, Apple, with its latest 10-K fetched from SEC EDGAR, and three fields marked high-risk so that every value goes to review. It ran as a trial because the demo schema was not released by an approver; the pipeline is the same. The run cost about 36 US cents. It found research and development expense of 34,550 million dollars for fiscal 2025 and about 166,000 full-time equivalent employees, each with its verbatim quote. Capital expenditure came back as not disclosed, which also goes to review. The scale and period checks flagged questions on each value, so a person decides.</a:t>
+              <a:t>A real run, made for this deck on 26 October 2026, with the built-in green capex preset: total capex, green capex, green capex share and EU Taxonomy-aligned capex, all high-risk fields, so every value goes to review. ARP fetched Signify's latest annual report from the ESEF filing index by its LEI. It found, for 2025, EUR 230.5 million total capex, of which EUR 211.5 million Taxonomy-eligible and EUR 101.4 million Taxonomy-aligned, quoted from page 25 of 89 and grounded exactly. The prior-period check flagged the jump from EUR 40.1 million in 2024. Two prior-year values quoted only as bare numbers failed grounding and are marked not verified. The run cost about 53 US cents and ran as a trial because the demo schema was not released by an approver.</a:t>
             </a:r>
           </a:p>
           <a:p/>
@@ -68621,7 +68621,7 @@
                 </a:solidFill>
                 <a:latin typeface="IBM Plex Sans"/>
               </a:rPr>
-              <a:t>One real value, ready for review</a:t>
+              <a:t>Green capex, extracted and checked</a:t>
             </a:r>
           </a:p>
         </p:txBody>
@@ -68635,7 +68635,7 @@
         <p:spPr>
           <a:xfrm>
             <a:off x="812800" y="1625600"/>
-            <a:ext cx="10566400" cy="247650"/>
+            <a:ext cx="10566400" cy="495300"/>
           </a:xfrm>
           <a:prstGeom prst="rect">
             <a:avLst/>
@@ -68663,14 +68663,14 @@
                 </a:solidFill>
                 <a:latin typeface="IBM Plex Sans"/>
               </a:rPr>
-              <a:t>Apple's latest 10-K, read live: every figure arrives with its quote, its page and both models' confidence.</a:t>
+              <a:t>Signify's 2025 annual report, read live from its ESEF filing: EUR 101.4m of EUR 230.5m capex is EU Taxonomy-aligned.</a:t>
             </a:r>
           </a:p>
         </p:txBody>
       </p:sp>
       <p:pic>
         <p:nvPicPr>
-          <p:cNvPr id="5" name="Picture 4" descr="review-tight.png"/>
+          <p:cNvPr id="5" name="Picture 4" descr="green-review.png"/>
           <p:cNvPicPr>
             <a:picLocks noChangeAspect="1"/>
           </p:cNvPicPr>
@@ -68684,8 +68684,8 @@
         </p:blipFill>
         <p:spPr>
           <a:xfrm>
-            <a:off x="812800" y="2101850"/>
-            <a:ext cx="8098064" cy="2152650"/>
+            <a:off x="812800" y="2349500"/>
+            <a:ext cx="7203575" cy="2368550"/>
           </a:xfrm>
           <a:prstGeom prst="rect">
             <a:avLst/>
@@ -68700,12 +68700,12 @@
         </p:nvSpPr>
         <p:spPr>
           <a:xfrm>
-            <a:off x="812800" y="2101850"/>
-            <a:ext cx="8098064" cy="2152650"/>
+            <a:off x="812800" y="2349500"/>
+            <a:ext cx="7203575" cy="2368550"/>
           </a:xfrm>
           <a:prstGeom prst="roundRect">
             <a:avLst>
-              <a:gd name="adj" fmla="val 4719"/>
+              <a:gd name="adj" fmla="val 4289"/>
             </a:avLst>
           </a:prstGeom>
           <a:noFill/>
@@ -68740,7 +68740,7 @@
         </p:blipFill>
         <p:spPr>
           <a:xfrm>
-            <a:off x="812800" y="4432300"/>
+            <a:off x="812800" y="4895850"/>
             <a:ext cx="406400" cy="406400"/>
           </a:xfrm>
           <a:prstGeom prst="rect">
@@ -68756,8 +68756,8 @@
         </p:nvSpPr>
         <p:spPr>
           <a:xfrm>
-            <a:off x="1320800" y="4432300"/>
-            <a:ext cx="2019300" cy="1409700"/>
+            <a:off x="1320800" y="4895850"/>
+            <a:ext cx="2019300" cy="946150"/>
           </a:xfrm>
           <a:prstGeom prst="rect">
             <a:avLst/>
@@ -68785,7 +68785,7 @@
                 </a:solidFill>
                 <a:latin typeface="IBM Plex Sans"/>
               </a:rPr>
-              <a:t>Extracted: 166,000 employees</a:t>
+              <a:t>Extracted: EUR 101.4m</a:t>
             </a:r>
           </a:p>
           <a:p>
@@ -68804,7 +68804,7 @@
                 </a:solidFill>
                 <a:latin typeface="IBM Plex Sans"/>
               </a:rPr>
-              <a:t>The extractor quoted the 10-K word for word, at 0.90 confidence.</a:t>
+              <a:t>Quoted word for word from the EU Taxonomy note.</a:t>
             </a:r>
           </a:p>
         </p:txBody>
@@ -68825,7 +68825,7 @@
         </p:blipFill>
         <p:spPr>
           <a:xfrm>
-            <a:off x="3492500" y="4432300"/>
+            <a:off x="3492500" y="4895850"/>
             <a:ext cx="406400" cy="406400"/>
           </a:xfrm>
           <a:prstGeom prst="rect">
@@ -68841,8 +68841,8 @@
         </p:nvSpPr>
         <p:spPr>
           <a:xfrm>
-            <a:off x="4000500" y="4432300"/>
-            <a:ext cx="2019300" cy="1409700"/>
+            <a:off x="4000500" y="4895850"/>
+            <a:ext cx="2019300" cy="946150"/>
           </a:xfrm>
           <a:prstGeom prst="rect">
             <a:avLst/>
@@ -68870,7 +68870,7 @@
                 </a:solidFill>
                 <a:latin typeface="IBM Plex Sans"/>
               </a:rPr>
-              <a:t>Confirmed by a second model</a:t>
+              <a:t>A second model agrees</a:t>
             </a:r>
           </a:p>
           <a:p>
@@ -68889,7 +68889,7 @@
                 </a:solidFill>
                 <a:latin typeface="IBM Plex Sans"/>
               </a:rPr>
-              <a:t>A different model extracted it blind and agreed, at 0.93.</a:t>
+              <a:t>A different model extracted it blind: 0.85.</a:t>
             </a:r>
           </a:p>
         </p:txBody>
@@ -68910,7 +68910,7 @@
         </p:blipFill>
         <p:spPr>
           <a:xfrm>
-            <a:off x="6172200" y="4432300"/>
+            <a:off x="6172200" y="4895850"/>
             <a:ext cx="406400" cy="406400"/>
           </a:xfrm>
           <a:prstGeom prst="rect">
@@ -68926,8 +68926,8 @@
         </p:nvSpPr>
         <p:spPr>
           <a:xfrm>
-            <a:off x="6680200" y="4432300"/>
-            <a:ext cx="2019300" cy="1409700"/>
+            <a:off x="6680200" y="4895850"/>
+            <a:ext cx="2019300" cy="946150"/>
           </a:xfrm>
           <a:prstGeom prst="rect">
             <a:avLst/>
@@ -68955,7 +68955,7 @@
                 </a:solidFill>
                 <a:latin typeface="IBM Plex Sans"/>
               </a:rPr>
-              <a:t>Found on page 3 of 23</a:t>
+              <a:t>Grounded on page 25</a:t>
             </a:r>
           </a:p>
           <a:p>
@@ -68974,7 +68974,7 @@
                 </a:solidFill>
                 <a:latin typeface="IBM Plex Sans"/>
               </a:rPr>
-              <a:t>Code located the quote in the stored 10-K; the reviewer sees it highlighted.</a:t>
+              <a:t>Code found the exact quote; a bare '40.1' failed.</a:t>
             </a:r>
           </a:p>
         </p:txBody>
@@ -68995,7 +68995,7 @@
         </p:blipFill>
         <p:spPr>
           <a:xfrm>
-            <a:off x="8851900" y="4432300"/>
+            <a:off x="8851900" y="4895850"/>
             <a:ext cx="406400" cy="406400"/>
           </a:xfrm>
           <a:prstGeom prst="rect">
@@ -69011,8 +69011,8 @@
         </p:nvSpPr>
         <p:spPr>
           <a:xfrm>
-            <a:off x="9359900" y="4432300"/>
-            <a:ext cx="2019300" cy="1409700"/>
+            <a:off x="9359900" y="4895850"/>
+            <a:ext cx="2019300" cy="946150"/>
           </a:xfrm>
           <a:prstGeom prst="rect">
             <a:avLst/>
@@ -69059,7 +69059,7 @@
                 </a:solidFill>
                 <a:latin typeface="IBM Plex Sans"/>
               </a:rPr>
-              <a:t>The period check flagged the date: accept, correct, reject or escalate. Every decision is kept.</a:t>
+              <a:t>The jump from EUR 40.1m in 2024 is flagged.</a:t>
             </a:r>
           </a:p>
         </p:txBody>

</xml_diff>